<commit_message>
Sesión 04: reducir a 28 diapositivas
Co-Authored-By: Claude Sonnet 5.5 <noreply@anthropic.com>
Claude-Session: https://claude.ai/code/session_0196T8tXAr6RMKpJodyvA85G
</commit_message>
<xml_diff>
--- a/Sesion_04.pptx
+++ b/Sesion_04.pptx
@@ -14,29 +14,18 @@
     <p:sldId id="259" r:id="rId5"/>
     <p:sldId id="309" r:id="rId37"/>
     <p:sldId id="310" r:id="rId38"/>
-    <p:sldId id="260" r:id="rId6"/>
     <p:sldId id="311" r:id="rId39"/>
-    <p:sldId id="312" r:id="rId40"/>
     <p:sldId id="313" r:id="rId41"/>
     <p:sldId id="314" r:id="rId42"/>
-    <p:sldId id="315" r:id="rId43"/>
-    <p:sldId id="316" r:id="rId44"/>
     <p:sldId id="317" r:id="rId45"/>
-    <p:sldId id="268" r:id="rId11"/>
     <p:sldId id="318" r:id="rId46"/>
     <p:sldId id="319" r:id="rId47"/>
     <p:sldId id="320" r:id="rId48"/>
     <p:sldId id="321" r:id="rId49"/>
-    <p:sldId id="322" r:id="rId50"/>
-    <p:sldId id="275" r:id="rId15"/>
     <p:sldId id="323" r:id="rId51"/>
-    <p:sldId id="324" r:id="rId52"/>
-    <p:sldId id="325" r:id="rId53"/>
     <p:sldId id="326" r:id="rId54"/>
     <p:sldId id="327" r:id="rId55"/>
-    <p:sldId id="283" r:id="rId19"/>
     <p:sldId id="308" r:id="rId29"/>
-    <p:sldId id="328" r:id="rId56"/>
     <p:sldId id="329" r:id="rId57"/>
     <p:sldId id="330" r:id="rId58"/>
     <p:sldId id="331" r:id="rId59"/>
@@ -44,7 +33,6 @@
     <p:sldId id="333" r:id="rId61"/>
     <p:sldId id="334" r:id="rId62"/>
     <p:sldId id="335" r:id="rId63"/>
-    <p:sldId id="336" r:id="rId64"/>
     <p:sldId id="337" r:id="rId65"/>
     <p:sldId id="338" r:id="rId66"/>
     <p:sldId id="339" r:id="rId67"/>
@@ -4110,387 +4098,6 @@
 </p:sld>
 </file>
 
-<file path=ppt/slides/slide10.xml><?xml version="1.0" encoding="utf-8"?>
-<p:sld xmlns:a="http://schemas.openxmlformats.org/drawingml/2006/main" xmlns:r="http://schemas.openxmlformats.org/officeDocument/2006/relationships" xmlns:p="http://schemas.openxmlformats.org/presentationml/2006/main">
-  <p:cSld>
-    <p:spTree>
-      <p:nvGrpSpPr>
-        <p:cNvPr id="1" name=""/>
-        <p:cNvGrpSpPr/>
-        <p:nvPr/>
-      </p:nvGrpSpPr>
-      <p:grpSpPr>
-        <a:xfrm>
-          <a:off x="0" y="0"/>
-          <a:ext cx="0" cy="0"/>
-          <a:chOff x="0" y="0"/>
-          <a:chExt cx="0" cy="0"/>
-        </a:xfrm>
-      </p:grpSpPr>
-      <p:pic>
-        <p:nvPicPr>
-          <p:cNvPr id="2" name="Picture 1" descr="divider_bg.png"/>
-          <p:cNvPicPr>
-            <a:picLocks noChangeAspect="1"/>
-          </p:cNvPicPr>
-          <p:nvPr/>
-        </p:nvPicPr>
-        <p:blipFill>
-          <a:blip r:embed="rId2"/>
-          <a:stretch>
-            <a:fillRect/>
-          </a:stretch>
-        </p:blipFill>
-        <p:spPr>
-          <a:xfrm>
-            <a:off x="0" y="0"/>
-            <a:ext cx="12191695" cy="6858000"/>
-          </a:xfrm>
-          <a:prstGeom prst="rect">
-            <a:avLst/>
-          </a:prstGeom>
-        </p:spPr>
-      </p:pic>
-      <p:sp>
-        <p:nvSpPr>
-          <p:cNvPr id="3" name="TextBox 2"/>
-          <p:cNvSpPr txBox="1"/>
-          <p:nvPr/>
-        </p:nvSpPr>
-        <p:spPr>
-          <a:xfrm>
-            <a:off x="982912" y="2676125"/>
-            <a:ext cx="437840" cy="1999910"/>
-          </a:xfrm>
-          <a:prstGeom prst="rect">
-            <a:avLst/>
-          </a:prstGeom>
-          <a:noFill/>
-        </p:spPr>
-        <p:txBody>
-          <a:bodyPr wrap="square">
-            <a:spAutoFit/>
-          </a:bodyPr>
-          <a:lstStyle/>
-          <a:p>
-            <a:pPr algn="l">
-              <a:lnSpc>
-                <a:spcPct val="115000"/>
-              </a:lnSpc>
-            </a:pPr>
-            <a:r>
-              <a:rPr sz="7200" b="1" i="0">
-                <a:solidFill>
-                  <a:srgbClr val="FFFFFF"/>
-                </a:solidFill>
-                <a:latin typeface="Calibri"/>
-              </a:rPr>
-              <a:t>2</a:t>
-            </a:r>
-          </a:p>
-        </p:txBody>
-      </p:sp>
-      <p:sp>
-        <p:nvSpPr>
-          <p:cNvPr id="4" name="TextBox 3"/>
-          <p:cNvSpPr txBox="1"/>
-          <p:nvPr/>
-        </p:nvSpPr>
-        <p:spPr>
-          <a:xfrm>
-            <a:off x="982912" y="4737409"/>
-            <a:ext cx="10346277" cy="702221"/>
-          </a:xfrm>
-          <a:prstGeom prst="rect">
-            <a:avLst/>
-          </a:prstGeom>
-          <a:noFill/>
-        </p:spPr>
-        <p:txBody>
-          <a:bodyPr wrap="square">
-            <a:spAutoFit/>
-          </a:bodyPr>
-          <a:lstStyle/>
-          <a:p>
-            <a:pPr algn="l">
-              <a:lnSpc>
-                <a:spcPct val="115000"/>
-              </a:lnSpc>
-            </a:pPr>
-            <a:r>
-              <a:rPr sz="2600" b="0" i="0">
-                <a:solidFill>
-                  <a:srgbClr val="FFFFFF"/>
-                </a:solidFill>
-                <a:latin typeface="Calibri"/>
-              </a:rPr>
-              <a:t>OPERADORES Y CONSTRUCCIÓN DE CADENAS</a:t>
-            </a:r>
-          </a:p>
-        </p:txBody>
-      </p:sp>
-    </p:spTree>
-  </p:cSld>
-  <p:clrMapOvr>
-    <a:masterClrMapping/>
-  </p:clrMapOvr>
-</p:sld>
-</file>
-
-<file path=ppt/slides/slide14.xml><?xml version="1.0" encoding="utf-8"?>
-<p:sld xmlns:a="http://schemas.openxmlformats.org/drawingml/2006/main" xmlns:r="http://schemas.openxmlformats.org/officeDocument/2006/relationships" xmlns:p="http://schemas.openxmlformats.org/presentationml/2006/main">
-  <p:cSld>
-    <p:spTree>
-      <p:nvGrpSpPr>
-        <p:cNvPr id="1" name=""/>
-        <p:cNvGrpSpPr/>
-        <p:nvPr/>
-      </p:nvGrpSpPr>
-      <p:grpSpPr>
-        <a:xfrm>
-          <a:off x="0" y="0"/>
-          <a:ext cx="0" cy="0"/>
-          <a:chOff x="0" y="0"/>
-          <a:chExt cx="0" cy="0"/>
-        </a:xfrm>
-      </p:grpSpPr>
-      <p:pic>
-        <p:nvPicPr>
-          <p:cNvPr id="2" name="Picture 1" descr="divider_bg.png"/>
-          <p:cNvPicPr>
-            <a:picLocks noChangeAspect="1"/>
-          </p:cNvPicPr>
-          <p:nvPr/>
-        </p:nvPicPr>
-        <p:blipFill>
-          <a:blip r:embed="rId2"/>
-          <a:stretch>
-            <a:fillRect/>
-          </a:stretch>
-        </p:blipFill>
-        <p:spPr>
-          <a:xfrm>
-            <a:off x="0" y="0"/>
-            <a:ext cx="12191695" cy="6858000"/>
-          </a:xfrm>
-          <a:prstGeom prst="rect">
-            <a:avLst/>
-          </a:prstGeom>
-        </p:spPr>
-      </p:pic>
-      <p:sp>
-        <p:nvSpPr>
-          <p:cNvPr id="3" name="TextBox 2"/>
-          <p:cNvSpPr txBox="1"/>
-          <p:nvPr/>
-        </p:nvSpPr>
-        <p:spPr>
-          <a:xfrm>
-            <a:off x="982912" y="2676125"/>
-            <a:ext cx="437840" cy="1999910"/>
-          </a:xfrm>
-          <a:prstGeom prst="rect">
-            <a:avLst/>
-          </a:prstGeom>
-          <a:noFill/>
-        </p:spPr>
-        <p:txBody>
-          <a:bodyPr wrap="square">
-            <a:spAutoFit/>
-          </a:bodyPr>
-          <a:lstStyle/>
-          <a:p>
-            <a:pPr algn="l">
-              <a:lnSpc>
-                <a:spcPct val="115000"/>
-              </a:lnSpc>
-            </a:pPr>
-            <a:r>
-              <a:rPr sz="7200" b="1" i="0">
-                <a:solidFill>
-                  <a:srgbClr val="FFFFFF"/>
-                </a:solidFill>
-                <a:latin typeface="Calibri"/>
-              </a:rPr>
-              <a:t>3</a:t>
-            </a:r>
-          </a:p>
-        </p:txBody>
-      </p:sp>
-      <p:sp>
-        <p:nvSpPr>
-          <p:cNvPr id="4" name="TextBox 3"/>
-          <p:cNvSpPr txBox="1"/>
-          <p:nvPr/>
-        </p:nvSpPr>
-        <p:spPr>
-          <a:xfrm>
-            <a:off x="982912" y="4737409"/>
-            <a:ext cx="10346277" cy="702221"/>
-          </a:xfrm>
-          <a:prstGeom prst="rect">
-            <a:avLst/>
-          </a:prstGeom>
-          <a:noFill/>
-        </p:spPr>
-        <p:txBody>
-          <a:bodyPr wrap="square">
-            <a:spAutoFit/>
-          </a:bodyPr>
-          <a:lstStyle/>
-          <a:p>
-            <a:pPr algn="l">
-              <a:lnSpc>
-                <a:spcPct val="115000"/>
-              </a:lnSpc>
-            </a:pPr>
-            <a:r>
-              <a:rPr sz="2600" b="0" i="0">
-                <a:solidFill>
-                  <a:srgbClr val="FFFFFF"/>
-                </a:solidFill>
-                <a:latin typeface="Calibri"/>
-              </a:rPr>
-              <a:t>GOOGLE SCHOLAR E IA COMO APOYO</a:t>
-            </a:r>
-          </a:p>
-        </p:txBody>
-      </p:sp>
-    </p:spTree>
-  </p:cSld>
-  <p:clrMapOvr>
-    <a:masterClrMapping/>
-  </p:clrMapOvr>
-</p:sld>
-</file>
-
-<file path=ppt/slides/slide18.xml><?xml version="1.0" encoding="utf-8"?>
-<p:sld xmlns:a="http://schemas.openxmlformats.org/drawingml/2006/main" xmlns:r="http://schemas.openxmlformats.org/officeDocument/2006/relationships" xmlns:p="http://schemas.openxmlformats.org/presentationml/2006/main">
-  <p:cSld>
-    <p:spTree>
-      <p:nvGrpSpPr>
-        <p:cNvPr id="1" name=""/>
-        <p:cNvGrpSpPr/>
-        <p:nvPr/>
-      </p:nvGrpSpPr>
-      <p:grpSpPr>
-        <a:xfrm>
-          <a:off x="0" y="0"/>
-          <a:ext cx="0" cy="0"/>
-          <a:chOff x="0" y="0"/>
-          <a:chExt cx="0" cy="0"/>
-        </a:xfrm>
-      </p:grpSpPr>
-      <p:pic>
-        <p:nvPicPr>
-          <p:cNvPr id="2" name="Picture 1" descr="divider_bg.png"/>
-          <p:cNvPicPr>
-            <a:picLocks noChangeAspect="1"/>
-          </p:cNvPicPr>
-          <p:nvPr/>
-        </p:nvPicPr>
-        <p:blipFill>
-          <a:blip r:embed="rId2"/>
-          <a:stretch>
-            <a:fillRect/>
-          </a:stretch>
-        </p:blipFill>
-        <p:spPr>
-          <a:xfrm>
-            <a:off x="0" y="0"/>
-            <a:ext cx="12191695" cy="6858000"/>
-          </a:xfrm>
-          <a:prstGeom prst="rect">
-            <a:avLst/>
-          </a:prstGeom>
-        </p:spPr>
-      </p:pic>
-      <p:sp>
-        <p:nvSpPr>
-          <p:cNvPr id="3" name="TextBox 2"/>
-          <p:cNvSpPr txBox="1"/>
-          <p:nvPr/>
-        </p:nvSpPr>
-        <p:spPr>
-          <a:xfrm>
-            <a:off x="982912" y="2676125"/>
-            <a:ext cx="437840" cy="1999910"/>
-          </a:xfrm>
-          <a:prstGeom prst="rect">
-            <a:avLst/>
-          </a:prstGeom>
-          <a:noFill/>
-        </p:spPr>
-        <p:txBody>
-          <a:bodyPr wrap="square">
-            <a:spAutoFit/>
-          </a:bodyPr>
-          <a:lstStyle/>
-          <a:p>
-            <a:pPr algn="l">
-              <a:lnSpc>
-                <a:spcPct val="115000"/>
-              </a:lnSpc>
-            </a:pPr>
-            <a:r>
-              <a:rPr sz="7200" b="1" i="0">
-                <a:solidFill>
-                  <a:srgbClr val="FFFFFF"/>
-                </a:solidFill>
-                <a:latin typeface="Calibri"/>
-              </a:rPr>
-              <a:t>4</a:t>
-            </a:r>
-          </a:p>
-        </p:txBody>
-      </p:sp>
-      <p:sp>
-        <p:nvSpPr>
-          <p:cNvPr id="4" name="TextBox 3"/>
-          <p:cNvSpPr txBox="1"/>
-          <p:nvPr/>
-        </p:nvSpPr>
-        <p:spPr>
-          <a:xfrm>
-            <a:off x="982912" y="4737409"/>
-            <a:ext cx="10346277" cy="702221"/>
-          </a:xfrm>
-          <a:prstGeom prst="rect">
-            <a:avLst/>
-          </a:prstGeom>
-          <a:noFill/>
-        </p:spPr>
-        <p:txBody>
-          <a:bodyPr wrap="square">
-            <a:spAutoFit/>
-          </a:bodyPr>
-          <a:lstStyle/>
-          <a:p>
-            <a:pPr algn="l">
-              <a:lnSpc>
-                <a:spcPct val="115000"/>
-              </a:lnSpc>
-            </a:pPr>
-            <a:r>
-              <a:rPr sz="2600" b="0" i="0">
-                <a:solidFill>
-                  <a:srgbClr val="FFFFFF"/>
-                </a:solidFill>
-                <a:latin typeface="Calibri"/>
-              </a:rPr>
-              <a:t>PRÁCTICA DE BÚSQUEDA ACADÉMICA</a:t>
-            </a:r>
-          </a:p>
-        </p:txBody>
-      </p:sp>
-    </p:spTree>
-  </p:cSld>
-  <p:clrMapOvr>
-    <a:masterClrMapping/>
-  </p:clrMapOvr>
-</p:sld>
-</file>
-
 <file path=ppt/slides/slide2.xml><?xml version="1.0" encoding="utf-8"?>
 <p:sld xmlns:a="http://schemas.openxmlformats.org/drawingml/2006/main" xmlns:r="http://schemas.openxmlformats.org/officeDocument/2006/relationships" xmlns:p="http://schemas.openxmlformats.org/presentationml/2006/main">
   <p:cSld>
@@ -4541,6 +4148,10 @@
             </a:outerShdw>
           </a:effectLst>
         </p:spPr>
+        <p:txBody>
+          <a:bodyPr/>
+          <a:p/>
+        </p:txBody>
       </p:sp>
       <p:pic>
         <p:nvPicPr>
@@ -9906,438 +9517,6 @@
                 <a:latin typeface="Calibri"/>
               </a:rPr>
               <a:t>Buscar no es copiar el título de la tesis en la barra de texto.</a:t>
-            </a:r>
-          </a:p>
-        </p:txBody>
-      </p:sp>
-    </p:spTree>
-  </p:cSld>
-  <p:clrMapOvr>
-    <a:masterClrMapping/>
-  </p:clrMapOvr>
-</p:sld>
-</file>
-
-<file path=ppt/slides/slide34.xml><?xml version="1.0" encoding="utf-8"?>
-<p:sld xmlns:a="http://schemas.openxmlformats.org/drawingml/2006/main" xmlns:p="http://schemas.openxmlformats.org/presentationml/2006/main" xmlns:r="http://schemas.openxmlformats.org/officeDocument/2006/relationships">
-  <p:cSld>
-    <p:spTree>
-      <p:nvGrpSpPr>
-        <p:cNvPr id="1" name=""/>
-        <p:cNvGrpSpPr/>
-        <p:nvPr/>
-      </p:nvGrpSpPr>
-      <p:grpSpPr/>
-      <p:pic>
-        <p:nvPicPr>
-          <p:cNvPr id="2" name="Picture 1" descr="image.png"/>
-          <p:cNvPicPr>
-            <a:picLocks noChangeAspect="1"/>
-          </p:cNvPicPr>
-          <p:nvPr/>
-        </p:nvPicPr>
-        <p:blipFill>
-          <a:blip r:embed="rId2"/>
-          <a:stretch>
-            <a:fillRect/>
-          </a:stretch>
-        </p:blipFill>
-        <p:spPr>
-          <a:xfrm>
-            <a:off x="0" y="0"/>
-            <a:ext cx="12192000" cy="6858000"/>
-          </a:xfrm>
-          <a:prstGeom prst="rect">
-            <a:avLst/>
-          </a:prstGeom>
-        </p:spPr>
-      </p:pic>
-      <p:sp>
-        <p:nvSpPr>
-          <p:cNvPr id="3" name="TextBox 2"/>
-          <p:cNvSpPr txBox="1"/>
-          <p:nvPr/>
-        </p:nvSpPr>
-        <p:spPr>
-          <a:xfrm>
-            <a:off x="612648" y="777240"/>
-            <a:ext cx="10332720" cy="640080"/>
-          </a:xfrm>
-          <a:prstGeom prst="rect">
-            <a:avLst/>
-          </a:prstGeom>
-          <a:noFill/>
-        </p:spPr>
-        <p:txBody>
-          <a:bodyPr wrap="square" lIns="45720" rIns="45720" tIns="27432" bIns="27432" anchor="ctr">
-            <a:spAutoFit/>
-          </a:bodyPr>
-          <a:lstStyle/>
-          <a:p>
-            <a:pPr algn="l">
-              <a:spcAft>
-                <a:spcPts val="400"/>
-              </a:spcAft>
-            </a:pPr>
-            <a:r>
-              <a:rPr sz="2800" b="1" i="0">
-                <a:solidFill>
-                  <a:srgbClr val="1836B2"/>
-                </a:solidFill>
-                <a:latin typeface="Calibri"/>
-              </a:rPr>
-              <a:t>De la pregunta a la necesidad de información</a:t>
-            </a:r>
-          </a:p>
-        </p:txBody>
-      </p:sp>
-      <p:sp>
-        <p:nvSpPr>
-          <p:cNvPr id="4" name="Rounded Rectangle 3"/>
-          <p:cNvSpPr/>
-          <p:nvPr/>
-        </p:nvSpPr>
-        <p:spPr>
-          <a:xfrm>
-            <a:off x="612648" y="1600200"/>
-            <a:ext cx="5394960" cy="3566160"/>
-          </a:xfrm>
-          <a:prstGeom prst="roundRect">
-            <a:avLst>
-              <a:gd name="adj" fmla="val 6000"/>
-            </a:avLst>
-          </a:prstGeom>
-          <a:solidFill>
-            <a:srgbClr val="011754"/>
-          </a:solidFill>
-          <a:ln>
-            <a:noFill/>
-          </a:ln>
-          <a:effectLst/>
-        </p:spPr>
-        <p:style>
-          <a:lnRef idx="1">
-            <a:schemeClr val="accent1"/>
-          </a:lnRef>
-          <a:fillRef idx="3">
-            <a:schemeClr val="accent1"/>
-          </a:fillRef>
-          <a:effectRef idx="2">
-            <a:schemeClr val="accent1"/>
-          </a:effectRef>
-          <a:fontRef idx="minor">
-            <a:schemeClr val="lt1"/>
-          </a:fontRef>
-        </p:style>
-        <p:txBody>
-          <a:bodyPr rtlCol="0" anchor="ctr"/>
-          <a:lstStyle/>
-          <a:p>
-            <a:pPr algn="ctr"/>
-          </a:p>
-        </p:txBody>
-      </p:sp>
-      <p:sp>
-        <p:nvSpPr>
-          <p:cNvPr id="5" name="TextBox 4"/>
-          <p:cNvSpPr txBox="1"/>
-          <p:nvPr/>
-        </p:nvSpPr>
-        <p:spPr>
-          <a:xfrm>
-            <a:off x="841248" y="1691640"/>
-            <a:ext cx="4937760" cy="3383280"/>
-          </a:xfrm>
-          <a:prstGeom prst="rect">
-            <a:avLst/>
-          </a:prstGeom>
-          <a:noFill/>
-        </p:spPr>
-        <p:txBody>
-          <a:bodyPr wrap="square" lIns="45720" rIns="45720" tIns="27432" bIns="27432" anchor="t">
-            <a:spAutoFit/>
-          </a:bodyPr>
-          <a:lstStyle/>
-          <a:p>
-            <a:pPr algn="l">
-              <a:spcAft>
-                <a:spcPts val="800"/>
-              </a:spcAft>
-            </a:pPr>
-            <a:r>
-              <a:rPr sz="2000" b="1" i="0">
-                <a:solidFill>
-                  <a:srgbClr val="D4AF37"/>
-                </a:solidFill>
-                <a:latin typeface="Calibri"/>
-              </a:rPr>
-              <a:t>Copiar el título</a:t>
-            </a:r>
-          </a:p>
-          <a:p>
-            <a:pPr algn="l">
-              <a:spcAft>
-                <a:spcPts val="1000"/>
-              </a:spcAft>
-            </a:pPr>
-            <a:r>
-              <a:rPr sz="1800" b="0" i="1">
-                <a:solidFill>
-                  <a:srgbClr val="FFFFFF"/>
-                </a:solidFill>
-                <a:latin typeface="Calibri"/>
-              </a:rPr>
-              <a:t>«Relación entre el uso de la inteligencia artificial generativa y el aprendizaje autónomo en estudiantes universitarios»</a:t>
-            </a:r>
-          </a:p>
-          <a:p>
-            <a:pPr algn="l">
-              <a:spcAft>
-                <a:spcPts val="400"/>
-              </a:spcAft>
-            </a:pPr>
-            <a:r>
-              <a:rPr sz="1800" b="0" i="0">
-                <a:solidFill>
-                  <a:srgbClr val="FFFFFF"/>
-                </a:solidFill>
-                <a:latin typeface="Calibri"/>
-              </a:rPr>
-              <a:t>Resultado: pocas coincidencias exactas, ruido y literatura clave que no aparece.</a:t>
-            </a:r>
-          </a:p>
-        </p:txBody>
-      </p:sp>
-      <p:sp>
-        <p:nvSpPr>
-          <p:cNvPr id="6" name="Rounded Rectangle 5"/>
-          <p:cNvSpPr/>
-          <p:nvPr/>
-        </p:nvSpPr>
-        <p:spPr>
-          <a:xfrm>
-            <a:off x="6190488" y="1600200"/>
-            <a:ext cx="5394960" cy="3566160"/>
-          </a:xfrm>
-          <a:prstGeom prst="roundRect">
-            <a:avLst>
-              <a:gd name="adj" fmla="val 6000"/>
-            </a:avLst>
-          </a:prstGeom>
-          <a:solidFill>
-            <a:srgbClr val="D9DEEF"/>
-          </a:solidFill>
-          <a:ln>
-            <a:noFill/>
-          </a:ln>
-          <a:effectLst/>
-        </p:spPr>
-        <p:style>
-          <a:lnRef idx="1">
-            <a:schemeClr val="accent1"/>
-          </a:lnRef>
-          <a:fillRef idx="3">
-            <a:schemeClr val="accent1"/>
-          </a:fillRef>
-          <a:effectRef idx="2">
-            <a:schemeClr val="accent1"/>
-          </a:effectRef>
-          <a:fontRef idx="minor">
-            <a:schemeClr val="lt1"/>
-          </a:fontRef>
-        </p:style>
-        <p:txBody>
-          <a:bodyPr rtlCol="0" anchor="ctr"/>
-          <a:lstStyle/>
-          <a:p>
-            <a:pPr algn="ctr"/>
-          </a:p>
-        </p:txBody>
-      </p:sp>
-      <p:sp>
-        <p:nvSpPr>
-          <p:cNvPr id="7" name="TextBox 6"/>
-          <p:cNvSpPr txBox="1"/>
-          <p:nvPr/>
-        </p:nvSpPr>
-        <p:spPr>
-          <a:xfrm>
-            <a:off x="6419088" y="1691640"/>
-            <a:ext cx="4937760" cy="3383280"/>
-          </a:xfrm>
-          <a:prstGeom prst="rect">
-            <a:avLst/>
-          </a:prstGeom>
-          <a:noFill/>
-        </p:spPr>
-        <p:txBody>
-          <a:bodyPr wrap="square" lIns="45720" rIns="45720" tIns="27432" bIns="27432" anchor="t">
-            <a:spAutoFit/>
-          </a:bodyPr>
-          <a:lstStyle/>
-          <a:p>
-            <a:pPr algn="l">
-              <a:spcAft>
-                <a:spcPts val="800"/>
-              </a:spcAft>
-            </a:pPr>
-            <a:r>
-              <a:rPr sz="2000" b="1" i="0">
-                <a:solidFill>
-                  <a:srgbClr val="2B4EB4"/>
-                </a:solidFill>
-                <a:latin typeface="Calibri"/>
-              </a:rPr>
-              <a:t>Descomponer en conceptos</a:t>
-            </a:r>
-          </a:p>
-          <a:p>
-            <a:pPr algn="l">
-              <a:spcAft>
-                <a:spcPts val="400"/>
-              </a:spcAft>
-            </a:pPr>
-            <a:r>
-              <a:rPr sz="1800" b="0" i="0">
-                <a:solidFill>
-                  <a:srgbClr val="011754"/>
-                </a:solidFill>
-                <a:latin typeface="Calibri"/>
-              </a:rPr>
-              <a:t>1. IA generativa</a:t>
-            </a:r>
-          </a:p>
-          <a:p>
-            <a:pPr algn="l">
-              <a:spcAft>
-                <a:spcPts val="400"/>
-              </a:spcAft>
-            </a:pPr>
-            <a:r>
-              <a:rPr sz="1800" b="0" i="0">
-                <a:solidFill>
-                  <a:srgbClr val="011754"/>
-                </a:solidFill>
-                <a:latin typeface="Calibri"/>
-              </a:rPr>
-              <a:t>2. Aprendizaje autónomo</a:t>
-            </a:r>
-          </a:p>
-          <a:p>
-            <a:pPr algn="l">
-              <a:spcAft>
-                <a:spcPts val="1000"/>
-              </a:spcAft>
-            </a:pPr>
-            <a:r>
-              <a:rPr sz="1800" b="0" i="0">
-                <a:solidFill>
-                  <a:srgbClr val="011754"/>
-                </a:solidFill>
-                <a:latin typeface="Calibri"/>
-              </a:rPr>
-              <a:t>3. Estudiantes universitarios</a:t>
-            </a:r>
-          </a:p>
-          <a:p>
-            <a:pPr algn="l">
-              <a:spcAft>
-                <a:spcPts val="400"/>
-              </a:spcAft>
-            </a:pPr>
-            <a:r>
-              <a:rPr sz="1800" b="1" i="0">
-                <a:solidFill>
-                  <a:srgbClr val="2B4EB4"/>
-                </a:solidFill>
-                <a:latin typeface="Calibri"/>
-              </a:rPr>
-              <a:t>Cada concepto se busca con varios términos y luego se combinan con operadores.</a:t>
-            </a:r>
-          </a:p>
-        </p:txBody>
-      </p:sp>
-      <p:sp>
-        <p:nvSpPr>
-          <p:cNvPr id="8" name="Rounded Rectangle 7"/>
-          <p:cNvSpPr/>
-          <p:nvPr/>
-        </p:nvSpPr>
-        <p:spPr>
-          <a:xfrm>
-            <a:off x="612648" y="5440680"/>
-            <a:ext cx="10972800" cy="731520"/>
-          </a:xfrm>
-          <a:prstGeom prst="roundRect">
-            <a:avLst>
-              <a:gd name="adj" fmla="val 6000"/>
-            </a:avLst>
-          </a:prstGeom>
-          <a:solidFill>
-            <a:srgbClr val="011754"/>
-          </a:solidFill>
-          <a:ln>
-            <a:noFill/>
-          </a:ln>
-          <a:effectLst/>
-        </p:spPr>
-        <p:style>
-          <a:lnRef idx="1">
-            <a:schemeClr val="accent1"/>
-          </a:lnRef>
-          <a:fillRef idx="3">
-            <a:schemeClr val="accent1"/>
-          </a:fillRef>
-          <a:effectRef idx="2">
-            <a:schemeClr val="accent1"/>
-          </a:effectRef>
-          <a:fontRef idx="minor">
-            <a:schemeClr val="lt1"/>
-          </a:fontRef>
-        </p:style>
-        <p:txBody>
-          <a:bodyPr rtlCol="0" anchor="ctr"/>
-          <a:lstStyle/>
-          <a:p>
-            <a:pPr algn="ctr"/>
-          </a:p>
-        </p:txBody>
-      </p:sp>
-      <p:sp>
-        <p:nvSpPr>
-          <p:cNvPr id="9" name="TextBox 8"/>
-          <p:cNvSpPr txBox="1"/>
-          <p:nvPr/>
-        </p:nvSpPr>
-        <p:spPr>
-          <a:xfrm>
-            <a:off x="841248" y="5440680"/>
-            <a:ext cx="10515600" cy="731520"/>
-          </a:xfrm>
-          <a:prstGeom prst="rect">
-            <a:avLst/>
-          </a:prstGeom>
-          <a:noFill/>
-        </p:spPr>
-        <p:txBody>
-          <a:bodyPr wrap="square" lIns="45720" rIns="45720" tIns="27432" bIns="27432" anchor="ctr">
-            <a:spAutoFit/>
-          </a:bodyPr>
-          <a:lstStyle/>
-          <a:p>
-            <a:pPr algn="l">
-              <a:spcAft>
-                <a:spcPts val="400"/>
-              </a:spcAft>
-            </a:pPr>
-            <a:r>
-              <a:rPr sz="1800" b="1" i="0">
-                <a:solidFill>
-                  <a:srgbClr val="FFFFFF"/>
-                </a:solidFill>
-                <a:latin typeface="Calibri"/>
-              </a:rPr>
-              <a:t>Una buena necesidad de información dice qué, en quién y en qué contexto se busca.</a:t>
             </a:r>
           </a:p>
         </p:txBody>
@@ -11479,1217 +10658,6 @@
 </p:sld>
 </file>
 
-<file path=ppt/slides/slide37.xml><?xml version="1.0" encoding="utf-8"?>
-<p:sld xmlns:a="http://schemas.openxmlformats.org/drawingml/2006/main" xmlns:p="http://schemas.openxmlformats.org/presentationml/2006/main" xmlns:r="http://schemas.openxmlformats.org/officeDocument/2006/relationships">
-  <p:cSld>
-    <p:spTree>
-      <p:nvGrpSpPr>
-        <p:cNvPr id="1" name=""/>
-        <p:cNvGrpSpPr/>
-        <p:nvPr/>
-      </p:nvGrpSpPr>
-      <p:grpSpPr/>
-      <p:pic>
-        <p:nvPicPr>
-          <p:cNvPr id="2" name="Picture 1" descr="image.png"/>
-          <p:cNvPicPr>
-            <a:picLocks noChangeAspect="1"/>
-          </p:cNvPicPr>
-          <p:nvPr/>
-        </p:nvPicPr>
-        <p:blipFill>
-          <a:blip r:embed="rId2"/>
-          <a:stretch>
-            <a:fillRect/>
-          </a:stretch>
-        </p:blipFill>
-        <p:spPr>
-          <a:xfrm>
-            <a:off x="0" y="0"/>
-            <a:ext cx="12192000" cy="6858000"/>
-          </a:xfrm>
-          <a:prstGeom prst="rect">
-            <a:avLst/>
-          </a:prstGeom>
-        </p:spPr>
-      </p:pic>
-      <p:sp>
-        <p:nvSpPr>
-          <p:cNvPr id="3" name="TextBox 2"/>
-          <p:cNvSpPr txBox="1"/>
-          <p:nvPr/>
-        </p:nvSpPr>
-        <p:spPr>
-          <a:xfrm>
-            <a:off x="612648" y="777240"/>
-            <a:ext cx="10332720" cy="640080"/>
-          </a:xfrm>
-          <a:prstGeom prst="rect">
-            <a:avLst/>
-          </a:prstGeom>
-          <a:noFill/>
-        </p:spPr>
-        <p:txBody>
-          <a:bodyPr wrap="square" lIns="45720" rIns="45720" tIns="27432" bIns="27432" anchor="ctr">
-            <a:spAutoFit/>
-          </a:bodyPr>
-          <a:lstStyle/>
-          <a:p>
-            <a:pPr algn="l">
-              <a:spcAft>
-                <a:spcPts val="400"/>
-              </a:spcAft>
-            </a:pPr>
-            <a:r>
-              <a:rPr sz="2800" b="1" i="0">
-                <a:solidFill>
-                  <a:srgbClr val="1836B2"/>
-                </a:solidFill>
-                <a:latin typeface="Calibri"/>
-              </a:rPr>
-              <a:t>Equivalencias en español y en inglés</a:t>
-            </a:r>
-          </a:p>
-        </p:txBody>
-      </p:sp>
-      <p:graphicFrame>
-        <p:nvGraphicFramePr>
-          <p:cNvPr id="4" name="Table 3"/>
-          <p:cNvGraphicFramePr>
-            <a:graphicFrameLocks noGrp="1"/>
-          </p:cNvGraphicFramePr>
-          <p:nvPr/>
-        </p:nvGraphicFramePr>
-        <p:xfrm>
-          <a:off x="612648" y="1600200"/>
-          <a:ext cx="10972800" cy="2880360"/>
-        </p:xfrm>
-        <a:graphic>
-          <a:graphicData uri="http://schemas.openxmlformats.org/drawingml/2006/table">
-            <a:tbl>
-              <a:tblPr firstRow="1" bandRow="1">
-                <a:tableStyleId>{5C22544A-7EE6-4342-B048-85BDC9FD1C3A}</a:tableStyleId>
-              </a:tblPr>
-              <a:tblGrid>
-                <a:gridCol w="3840480"/>
-                <a:gridCol w="7132320"/>
-              </a:tblGrid>
-              <a:tr h="548640">
-                <a:tc>
-                  <a:txBody>
-                    <a:bodyPr wrap="square"/>
-                    <a:lstStyle/>
-                    <a:p>
-                      <a:pPr algn="l"/>
-                      <a:r>
-                        <a:rPr sz="1800" b="1">
-                          <a:solidFill>
-                            <a:srgbClr val="FFFFFF"/>
-                          </a:solidFill>
-                          <a:latin typeface="Calibri"/>
-                        </a:rPr>
-                        <a:t>Concepto en español</a:t>
-                      </a:r>
-                    </a:p>
-                  </a:txBody>
-                  <a:tcPr anchor="ctr" marL="109728" marR="109728">
-                    <a:solidFill>
-                      <a:srgbClr val="011754"/>
-                    </a:solidFill>
-                  </a:tcPr>
-                </a:tc>
-                <a:tc>
-                  <a:txBody>
-                    <a:bodyPr wrap="square"/>
-                    <a:lstStyle/>
-                    <a:p>
-                      <a:pPr algn="l"/>
-                      <a:r>
-                        <a:rPr sz="1800" b="1">
-                          <a:solidFill>
-                            <a:srgbClr val="FFFFFF"/>
-                          </a:solidFill>
-                          <a:latin typeface="Calibri"/>
-                        </a:rPr>
-                        <a:t>Equivalentes en inglés</a:t>
-                      </a:r>
-                    </a:p>
-                  </a:txBody>
-                  <a:tcPr anchor="ctr" marL="109728" marR="109728">
-                    <a:solidFill>
-                      <a:srgbClr val="011754"/>
-                    </a:solidFill>
-                  </a:tcPr>
-                </a:tc>
-              </a:tr>
-              <a:tr h="777240">
-                <a:tc>
-                  <a:txBody>
-                    <a:bodyPr wrap="square"/>
-                    <a:lstStyle/>
-                    <a:p>
-                      <a:pPr algn="l"/>
-                      <a:r>
-                        <a:rPr sz="1800" b="1">
-                          <a:solidFill>
-                            <a:srgbClr val="011754"/>
-                          </a:solidFill>
-                          <a:latin typeface="Calibri"/>
-                        </a:rPr>
-                        <a:t>IA generativa</a:t>
-                      </a:r>
-                    </a:p>
-                  </a:txBody>
-                  <a:tcPr anchor="ctr" marL="109728" marR="109728">
-                    <a:solidFill>
-                      <a:srgbClr val="D9DEEF"/>
-                    </a:solidFill>
-                  </a:tcPr>
-                </a:tc>
-                <a:tc>
-                  <a:txBody>
-                    <a:bodyPr wrap="square"/>
-                    <a:lstStyle/>
-                    <a:p>
-                      <a:pPr algn="l"/>
-                      <a:r>
-                        <a:rPr sz="1800" b="0">
-                          <a:solidFill>
-                            <a:srgbClr val="011754"/>
-                          </a:solidFill>
-                          <a:latin typeface="Calibri"/>
-                        </a:rPr>
-                        <a:t>"generative AI", "generative artificial intelligence"</a:t>
-                      </a:r>
-                    </a:p>
-                  </a:txBody>
-                  <a:tcPr anchor="ctr" marL="109728" marR="109728">
-                    <a:solidFill>
-                      <a:srgbClr val="D9DEEF"/>
-                    </a:solidFill>
-                  </a:tcPr>
-                </a:tc>
-              </a:tr>
-              <a:tr h="777240">
-                <a:tc>
-                  <a:txBody>
-                    <a:bodyPr wrap="square"/>
-                    <a:lstStyle/>
-                    <a:p>
-                      <a:pPr algn="l"/>
-                      <a:r>
-                        <a:rPr sz="1800" b="1">
-                          <a:solidFill>
-                            <a:srgbClr val="011754"/>
-                          </a:solidFill>
-                          <a:latin typeface="Calibri"/>
-                        </a:rPr>
-                        <a:t>Aprendizaje autónomo</a:t>
-                      </a:r>
-                    </a:p>
-                  </a:txBody>
-                  <a:tcPr anchor="ctr" marL="109728" marR="109728">
-                    <a:solidFill>
-                      <a:srgbClr val="FFFFFF"/>
-                    </a:solidFill>
-                  </a:tcPr>
-                </a:tc>
-                <a:tc>
-                  <a:txBody>
-                    <a:bodyPr wrap="square"/>
-                    <a:lstStyle/>
-                    <a:p>
-                      <a:pPr algn="l"/>
-                      <a:r>
-                        <a:rPr sz="1800" b="0">
-                          <a:solidFill>
-                            <a:srgbClr val="011754"/>
-                          </a:solidFill>
-                          <a:latin typeface="Calibri"/>
-                        </a:rPr>
-                        <a:t>"self-directed learning", "self-regulated learning", "learner autonomy"</a:t>
-                      </a:r>
-                    </a:p>
-                  </a:txBody>
-                  <a:tcPr anchor="ctr" marL="109728" marR="109728">
-                    <a:solidFill>
-                      <a:srgbClr val="FFFFFF"/>
-                    </a:solidFill>
-                  </a:tcPr>
-                </a:tc>
-              </a:tr>
-              <a:tr h="777240">
-                <a:tc>
-                  <a:txBody>
-                    <a:bodyPr wrap="square"/>
-                    <a:lstStyle/>
-                    <a:p>
-                      <a:pPr algn="l"/>
-                      <a:r>
-                        <a:rPr sz="1800" b="1">
-                          <a:solidFill>
-                            <a:srgbClr val="011754"/>
-                          </a:solidFill>
-                          <a:latin typeface="Calibri"/>
-                        </a:rPr>
-                        <a:t>Estudiantes universitarios</a:t>
-                      </a:r>
-                    </a:p>
-                  </a:txBody>
-                  <a:tcPr anchor="ctr" marL="109728" marR="109728">
-                    <a:solidFill>
-                      <a:srgbClr val="D9DEEF"/>
-                    </a:solidFill>
-                  </a:tcPr>
-                </a:tc>
-                <a:tc>
-                  <a:txBody>
-                    <a:bodyPr wrap="square"/>
-                    <a:lstStyle/>
-                    <a:p>
-                      <a:pPr algn="l"/>
-                      <a:r>
-                        <a:rPr sz="1800" b="0">
-                          <a:solidFill>
-                            <a:srgbClr val="011754"/>
-                          </a:solidFill>
-                          <a:latin typeface="Calibri"/>
-                        </a:rPr>
-                        <a:t>"university students", "college students", "higher education"</a:t>
-                      </a:r>
-                    </a:p>
-                  </a:txBody>
-                  <a:tcPr anchor="ctr" marL="109728" marR="109728">
-                    <a:solidFill>
-                      <a:srgbClr val="D9DEEF"/>
-                    </a:solidFill>
-                  </a:tcPr>
-                </a:tc>
-              </a:tr>
-            </a:tbl>
-          </a:graphicData>
-        </a:graphic>
-      </p:graphicFrame>
-      <p:sp>
-        <p:nvSpPr>
-          <p:cNvPr id="5" name="Rounded Rectangle 4"/>
-          <p:cNvSpPr/>
-          <p:nvPr/>
-        </p:nvSpPr>
-        <p:spPr>
-          <a:xfrm>
-            <a:off x="612648" y="4617720"/>
-            <a:ext cx="5394960" cy="1600200"/>
-          </a:xfrm>
-          <a:prstGeom prst="roundRect">
-            <a:avLst>
-              <a:gd name="adj" fmla="val 6000"/>
-            </a:avLst>
-          </a:prstGeom>
-          <a:solidFill>
-            <a:srgbClr val="D9DEEF"/>
-          </a:solidFill>
-          <a:ln>
-            <a:noFill/>
-          </a:ln>
-          <a:effectLst/>
-        </p:spPr>
-        <p:style>
-          <a:lnRef idx="1">
-            <a:schemeClr val="accent1"/>
-          </a:lnRef>
-          <a:fillRef idx="3">
-            <a:schemeClr val="accent1"/>
-          </a:fillRef>
-          <a:effectRef idx="2">
-            <a:schemeClr val="accent1"/>
-          </a:effectRef>
-          <a:fontRef idx="minor">
-            <a:schemeClr val="lt1"/>
-          </a:fontRef>
-        </p:style>
-        <p:txBody>
-          <a:bodyPr rtlCol="0" anchor="ctr"/>
-          <a:lstStyle/>
-          <a:p>
-            <a:pPr algn="ctr"/>
-          </a:p>
-        </p:txBody>
-      </p:sp>
-      <p:sp>
-        <p:nvSpPr>
-          <p:cNvPr id="6" name="TextBox 5"/>
-          <p:cNvSpPr txBox="1"/>
-          <p:nvPr/>
-        </p:nvSpPr>
-        <p:spPr>
-          <a:xfrm>
-            <a:off x="795528" y="4727448"/>
-            <a:ext cx="5029200" cy="1380744"/>
-          </a:xfrm>
-          <a:prstGeom prst="rect">
-            <a:avLst/>
-          </a:prstGeom>
-          <a:noFill/>
-        </p:spPr>
-        <p:txBody>
-          <a:bodyPr wrap="square" lIns="45720" rIns="45720" tIns="27432" bIns="27432" anchor="t">
-            <a:spAutoFit/>
-          </a:bodyPr>
-          <a:lstStyle/>
-          <a:p>
-            <a:pPr algn="l">
-              <a:spcAft>
-                <a:spcPts val="600"/>
-              </a:spcAft>
-            </a:pPr>
-            <a:r>
-              <a:rPr sz="2000" b="1" i="0">
-                <a:solidFill>
-                  <a:srgbClr val="2B4EB4"/>
-                </a:solidFill>
-                <a:latin typeface="Calibri"/>
-              </a:rPr>
-              <a:t>Por qué el inglés</a:t>
-            </a:r>
-          </a:p>
-          <a:p>
-            <a:pPr algn="l">
-              <a:spcAft>
-                <a:spcPts val="400"/>
-              </a:spcAft>
-            </a:pPr>
-            <a:r>
-              <a:rPr sz="1800" b="0" i="0">
-                <a:solidFill>
-                  <a:srgbClr val="011754"/>
-                </a:solidFill>
-                <a:latin typeface="Calibri"/>
-              </a:rPr>
-              <a:t>La mayor parte de la literatura indexada se publica en inglés; buscar solo en español recupera una fracción.</a:t>
-            </a:r>
-          </a:p>
-        </p:txBody>
-      </p:sp>
-      <p:sp>
-        <p:nvSpPr>
-          <p:cNvPr id="7" name="Rounded Rectangle 6"/>
-          <p:cNvSpPr/>
-          <p:nvPr/>
-        </p:nvSpPr>
-        <p:spPr>
-          <a:xfrm>
-            <a:off x="6190488" y="4617720"/>
-            <a:ext cx="5394960" cy="1600200"/>
-          </a:xfrm>
-          <a:prstGeom prst="roundRect">
-            <a:avLst>
-              <a:gd name="adj" fmla="val 6000"/>
-            </a:avLst>
-          </a:prstGeom>
-          <a:solidFill>
-            <a:srgbClr val="D9DEEF"/>
-          </a:solidFill>
-          <a:ln>
-            <a:noFill/>
-          </a:ln>
-          <a:effectLst/>
-        </p:spPr>
-        <p:style>
-          <a:lnRef idx="1">
-            <a:schemeClr val="accent1"/>
-          </a:lnRef>
-          <a:fillRef idx="3">
-            <a:schemeClr val="accent1"/>
-          </a:fillRef>
-          <a:effectRef idx="2">
-            <a:schemeClr val="accent1"/>
-          </a:effectRef>
-          <a:fontRef idx="minor">
-            <a:schemeClr val="lt1"/>
-          </a:fontRef>
-        </p:style>
-        <p:txBody>
-          <a:bodyPr rtlCol="0" anchor="ctr"/>
-          <a:lstStyle/>
-          <a:p>
-            <a:pPr algn="ctr"/>
-          </a:p>
-        </p:txBody>
-      </p:sp>
-      <p:sp>
-        <p:nvSpPr>
-          <p:cNvPr id="8" name="TextBox 7"/>
-          <p:cNvSpPr txBox="1"/>
-          <p:nvPr/>
-        </p:nvSpPr>
-        <p:spPr>
-          <a:xfrm>
-            <a:off x="6373368" y="4727448"/>
-            <a:ext cx="5029200" cy="1380744"/>
-          </a:xfrm>
-          <a:prstGeom prst="rect">
-            <a:avLst/>
-          </a:prstGeom>
-          <a:noFill/>
-        </p:spPr>
-        <p:txBody>
-          <a:bodyPr wrap="square" lIns="45720" rIns="45720" tIns="27432" bIns="27432" anchor="t">
-            <a:spAutoFit/>
-          </a:bodyPr>
-          <a:lstStyle/>
-          <a:p>
-            <a:pPr algn="l">
-              <a:spcAft>
-                <a:spcPts val="600"/>
-              </a:spcAft>
-            </a:pPr>
-            <a:r>
-              <a:rPr sz="2000" b="1" i="0">
-                <a:solidFill>
-                  <a:srgbClr val="2B4EB4"/>
-                </a:solidFill>
-                <a:latin typeface="Calibri"/>
-              </a:rPr>
-              <a:t>Cómo se verifica</a:t>
-            </a:r>
-          </a:p>
-          <a:p>
-            <a:pPr algn="l">
-              <a:spcAft>
-                <a:spcPts val="400"/>
-              </a:spcAft>
-            </a:pPr>
-            <a:r>
-              <a:rPr sz="1800" b="0" i="0">
-                <a:solidFill>
-                  <a:srgbClr val="011754"/>
-                </a:solidFill>
-                <a:latin typeface="Calibri"/>
-              </a:rPr>
-              <a:t>Un término es útil si aparece en títulos y resúmenes de artículos reales, no solo en una lista de la IA.</a:t>
-            </a:r>
-          </a:p>
-        </p:txBody>
-      </p:sp>
-    </p:spTree>
-  </p:cSld>
-  <p:clrMapOvr>
-    <a:masterClrMapping/>
-  </p:clrMapOvr>
-</p:sld>
-</file>
-
-<file path=ppt/slides/slide38.xml><?xml version="1.0" encoding="utf-8"?>
-<p:sld xmlns:a="http://schemas.openxmlformats.org/drawingml/2006/main" xmlns:p="http://schemas.openxmlformats.org/presentationml/2006/main" xmlns:r="http://schemas.openxmlformats.org/officeDocument/2006/relationships">
-  <p:cSld>
-    <p:spTree>
-      <p:nvGrpSpPr>
-        <p:cNvPr id="1" name=""/>
-        <p:cNvGrpSpPr/>
-        <p:nvPr/>
-      </p:nvGrpSpPr>
-      <p:grpSpPr/>
-      <p:pic>
-        <p:nvPicPr>
-          <p:cNvPr id="2" name="Picture 1" descr="image.png"/>
-          <p:cNvPicPr>
-            <a:picLocks noChangeAspect="1"/>
-          </p:cNvPicPr>
-          <p:nvPr/>
-        </p:nvPicPr>
-        <p:blipFill>
-          <a:blip r:embed="rId2"/>
-          <a:stretch>
-            <a:fillRect/>
-          </a:stretch>
-        </p:blipFill>
-        <p:spPr>
-          <a:xfrm>
-            <a:off x="0" y="0"/>
-            <a:ext cx="12192000" cy="6858000"/>
-          </a:xfrm>
-          <a:prstGeom prst="rect">
-            <a:avLst/>
-          </a:prstGeom>
-        </p:spPr>
-      </p:pic>
-      <p:sp>
-        <p:nvSpPr>
-          <p:cNvPr id="3" name="TextBox 2"/>
-          <p:cNvSpPr txBox="1"/>
-          <p:nvPr/>
-        </p:nvSpPr>
-        <p:spPr>
-          <a:xfrm>
-            <a:off x="612648" y="777240"/>
-            <a:ext cx="10332720" cy="640080"/>
-          </a:xfrm>
-          <a:prstGeom prst="rect">
-            <a:avLst/>
-          </a:prstGeom>
-          <a:noFill/>
-        </p:spPr>
-        <p:txBody>
-          <a:bodyPr wrap="square" lIns="45720" rIns="45720" tIns="27432" bIns="27432" anchor="ctr">
-            <a:spAutoFit/>
-          </a:bodyPr>
-          <a:lstStyle/>
-          <a:p>
-            <a:pPr algn="l">
-              <a:spcAft>
-                <a:spcPts val="400"/>
-              </a:spcAft>
-            </a:pPr>
-            <a:r>
-              <a:rPr sz="2800" b="1" i="0">
-                <a:solidFill>
-                  <a:srgbClr val="1836B2"/>
-                </a:solidFill>
-                <a:latin typeface="Calibri"/>
-              </a:rPr>
-              <a:t>Primero a mano, después con la IA</a:t>
-            </a:r>
-          </a:p>
-        </p:txBody>
-      </p:sp>
-      <p:sp>
-        <p:nvSpPr>
-          <p:cNvPr id="4" name="TextBox 3"/>
-          <p:cNvSpPr txBox="1"/>
-          <p:nvPr/>
-        </p:nvSpPr>
-        <p:spPr>
-          <a:xfrm>
-            <a:off x="612648" y="1463040"/>
-            <a:ext cx="10972800" cy="457200"/>
-          </a:xfrm>
-          <a:prstGeom prst="rect">
-            <a:avLst/>
-          </a:prstGeom>
-          <a:noFill/>
-        </p:spPr>
-        <p:txBody>
-          <a:bodyPr wrap="square" lIns="45720" rIns="45720" tIns="27432" bIns="27432" anchor="t">
-            <a:spAutoFit/>
-          </a:bodyPr>
-          <a:lstStyle/>
-          <a:p>
-            <a:pPr algn="l">
-              <a:spcAft>
-                <a:spcPts val="400"/>
-              </a:spcAft>
-            </a:pPr>
-            <a:r>
-              <a:rPr sz="1800" b="0" i="0">
-                <a:solidFill>
-                  <a:srgbClr val="011754"/>
-                </a:solidFill>
-                <a:latin typeface="Calibri"/>
-              </a:rPr>
-              <a:t>Antes de abrir un modelo de lenguaje, articula tu propio mapa de términos.</a:t>
-            </a:r>
-          </a:p>
-        </p:txBody>
-      </p:sp>
-      <p:sp>
-        <p:nvSpPr>
-          <p:cNvPr id="5" name="Rounded Rectangle 4"/>
-          <p:cNvSpPr/>
-          <p:nvPr/>
-        </p:nvSpPr>
-        <p:spPr>
-          <a:xfrm>
-            <a:off x="612648" y="2011680"/>
-            <a:ext cx="5394960" cy="1737360"/>
-          </a:xfrm>
-          <a:prstGeom prst="roundRect">
-            <a:avLst>
-              <a:gd name="adj" fmla="val 6000"/>
-            </a:avLst>
-          </a:prstGeom>
-          <a:solidFill>
-            <a:srgbClr val="D9DEEF"/>
-          </a:solidFill>
-          <a:ln>
-            <a:noFill/>
-          </a:ln>
-          <a:effectLst/>
-        </p:spPr>
-        <p:style>
-          <a:lnRef idx="1">
-            <a:schemeClr val="accent1"/>
-          </a:lnRef>
-          <a:fillRef idx="3">
-            <a:schemeClr val="accent1"/>
-          </a:fillRef>
-          <a:effectRef idx="2">
-            <a:schemeClr val="accent1"/>
-          </a:effectRef>
-          <a:fontRef idx="minor">
-            <a:schemeClr val="lt1"/>
-          </a:fontRef>
-        </p:style>
-        <p:txBody>
-          <a:bodyPr rtlCol="0" anchor="ctr"/>
-          <a:lstStyle/>
-          <a:p>
-            <a:pPr algn="ctr"/>
-          </a:p>
-        </p:txBody>
-      </p:sp>
-      <p:sp>
-        <p:nvSpPr>
-          <p:cNvPr id="6" name="TextBox 5"/>
-          <p:cNvSpPr txBox="1"/>
-          <p:nvPr/>
-        </p:nvSpPr>
-        <p:spPr>
-          <a:xfrm>
-            <a:off x="795528" y="2121408"/>
-            <a:ext cx="5029200" cy="1517904"/>
-          </a:xfrm>
-          <a:prstGeom prst="rect">
-            <a:avLst/>
-          </a:prstGeom>
-          <a:noFill/>
-        </p:spPr>
-        <p:txBody>
-          <a:bodyPr wrap="square" lIns="45720" rIns="45720" tIns="27432" bIns="27432" anchor="t">
-            <a:spAutoFit/>
-          </a:bodyPr>
-          <a:lstStyle/>
-          <a:p>
-            <a:pPr algn="l">
-              <a:spcAft>
-                <a:spcPts val="600"/>
-              </a:spcAft>
-            </a:pPr>
-            <a:r>
-              <a:rPr sz="2000" b="1" i="0">
-                <a:solidFill>
-                  <a:srgbClr val="2B4EB4"/>
-                </a:solidFill>
-                <a:latin typeface="Calibri"/>
-              </a:rPr>
-              <a:t>Concepto núcleo</a:t>
-            </a:r>
-          </a:p>
-          <a:p>
-            <a:pPr algn="l">
-              <a:spcAft>
-                <a:spcPts val="400"/>
-              </a:spcAft>
-            </a:pPr>
-            <a:r>
-              <a:rPr sz="1800" b="0" i="0">
-                <a:solidFill>
-                  <a:srgbClr val="011754"/>
-                </a:solidFill>
-                <a:latin typeface="Calibri"/>
-              </a:rPr>
-              <a:t>Inteligencia artificial generativa</a:t>
-            </a:r>
-          </a:p>
-        </p:txBody>
-      </p:sp>
-      <p:sp>
-        <p:nvSpPr>
-          <p:cNvPr id="7" name="Rounded Rectangle 6"/>
-          <p:cNvSpPr/>
-          <p:nvPr/>
-        </p:nvSpPr>
-        <p:spPr>
-          <a:xfrm>
-            <a:off x="6190488" y="2011680"/>
-            <a:ext cx="5394960" cy="1737360"/>
-          </a:xfrm>
-          <a:prstGeom prst="roundRect">
-            <a:avLst>
-              <a:gd name="adj" fmla="val 6000"/>
-            </a:avLst>
-          </a:prstGeom>
-          <a:solidFill>
-            <a:srgbClr val="D9DEEF"/>
-          </a:solidFill>
-          <a:ln>
-            <a:noFill/>
-          </a:ln>
-          <a:effectLst/>
-        </p:spPr>
-        <p:style>
-          <a:lnRef idx="1">
-            <a:schemeClr val="accent1"/>
-          </a:lnRef>
-          <a:fillRef idx="3">
-            <a:schemeClr val="accent1"/>
-          </a:fillRef>
-          <a:effectRef idx="2">
-            <a:schemeClr val="accent1"/>
-          </a:effectRef>
-          <a:fontRef idx="minor">
-            <a:schemeClr val="lt1"/>
-          </a:fontRef>
-        </p:style>
-        <p:txBody>
-          <a:bodyPr rtlCol="0" anchor="ctr"/>
-          <a:lstStyle/>
-          <a:p>
-            <a:pPr algn="ctr"/>
-          </a:p>
-        </p:txBody>
-      </p:sp>
-      <p:sp>
-        <p:nvSpPr>
-          <p:cNvPr id="8" name="TextBox 7"/>
-          <p:cNvSpPr txBox="1"/>
-          <p:nvPr/>
-        </p:nvSpPr>
-        <p:spPr>
-          <a:xfrm>
-            <a:off x="6373368" y="2121408"/>
-            <a:ext cx="5029200" cy="1517904"/>
-          </a:xfrm>
-          <a:prstGeom prst="rect">
-            <a:avLst/>
-          </a:prstGeom>
-          <a:noFill/>
-        </p:spPr>
-        <p:txBody>
-          <a:bodyPr wrap="square" lIns="45720" rIns="45720" tIns="27432" bIns="27432" anchor="t">
-            <a:spAutoFit/>
-          </a:bodyPr>
-          <a:lstStyle/>
-          <a:p>
-            <a:pPr algn="l">
-              <a:spcAft>
-                <a:spcPts val="600"/>
-              </a:spcAft>
-            </a:pPr>
-            <a:r>
-              <a:rPr sz="2000" b="1" i="0">
-                <a:solidFill>
-                  <a:srgbClr val="2B4EB4"/>
-                </a:solidFill>
-                <a:latin typeface="Calibri"/>
-              </a:rPr>
-              <a:t>Variantes y equivalentes</a:t>
-            </a:r>
-          </a:p>
-          <a:p>
-            <a:pPr algn="l">
-              <a:spcAft>
-                <a:spcPts val="400"/>
-              </a:spcAft>
-            </a:pPr>
-            <a:r>
-              <a:rPr sz="1800" b="0" i="0">
-                <a:solidFill>
-                  <a:srgbClr val="011754"/>
-                </a:solidFill>
-                <a:latin typeface="Calibri"/>
-              </a:rPr>
-              <a:t>Generative AI · GenAI · Large language models · LLMs</a:t>
-            </a:r>
-          </a:p>
-        </p:txBody>
-      </p:sp>
-      <p:sp>
-        <p:nvSpPr>
-          <p:cNvPr id="9" name="Rounded Rectangle 8"/>
-          <p:cNvSpPr/>
-          <p:nvPr/>
-        </p:nvSpPr>
-        <p:spPr>
-          <a:xfrm>
-            <a:off x="612648" y="3977639"/>
-            <a:ext cx="3535680" cy="1508760"/>
-          </a:xfrm>
-          <a:prstGeom prst="roundRect">
-            <a:avLst>
-              <a:gd name="adj" fmla="val 6000"/>
-            </a:avLst>
-          </a:prstGeom>
-          <a:solidFill>
-            <a:srgbClr val="D9DEEF"/>
-          </a:solidFill>
-          <a:ln>
-            <a:noFill/>
-          </a:ln>
-          <a:effectLst/>
-        </p:spPr>
-        <p:style>
-          <a:lnRef idx="1">
-            <a:schemeClr val="accent1"/>
-          </a:lnRef>
-          <a:fillRef idx="3">
-            <a:schemeClr val="accent1"/>
-          </a:fillRef>
-          <a:effectRef idx="2">
-            <a:schemeClr val="accent1"/>
-          </a:effectRef>
-          <a:fontRef idx="minor">
-            <a:schemeClr val="lt1"/>
-          </a:fontRef>
-        </p:style>
-        <p:txBody>
-          <a:bodyPr rtlCol="0" anchor="ctr"/>
-          <a:lstStyle/>
-          <a:p>
-            <a:pPr algn="ctr"/>
-          </a:p>
-        </p:txBody>
-      </p:sp>
-      <p:sp>
-        <p:nvSpPr>
-          <p:cNvPr id="10" name="TextBox 9"/>
-          <p:cNvSpPr txBox="1"/>
-          <p:nvPr/>
-        </p:nvSpPr>
-        <p:spPr>
-          <a:xfrm>
-            <a:off x="795528" y="4087368"/>
-            <a:ext cx="3169920" cy="1289304"/>
-          </a:xfrm>
-          <a:prstGeom prst="rect">
-            <a:avLst/>
-          </a:prstGeom>
-          <a:noFill/>
-        </p:spPr>
-        <p:txBody>
-          <a:bodyPr wrap="square" lIns="45720" rIns="45720" tIns="27432" bIns="27432" anchor="t">
-            <a:spAutoFit/>
-          </a:bodyPr>
-          <a:lstStyle/>
-          <a:p>
-            <a:pPr algn="l">
-              <a:spcAft>
-                <a:spcPts val="600"/>
-              </a:spcAft>
-            </a:pPr>
-            <a:r>
-              <a:rPr sz="2000" b="1" i="0">
-                <a:solidFill>
-                  <a:srgbClr val="2B4EB4"/>
-                </a:solidFill>
-                <a:latin typeface="Calibri"/>
-              </a:rPr>
-              <a:t>1. Escribe</a:t>
-            </a:r>
-          </a:p>
-          <a:p>
-            <a:pPr algn="l">
-              <a:spcAft>
-                <a:spcPts val="400"/>
-              </a:spcAft>
-            </a:pPr>
-            <a:r>
-              <a:rPr sz="1800" b="0" i="0">
-                <a:solidFill>
-                  <a:srgbClr val="011754"/>
-                </a:solidFill>
-                <a:latin typeface="Calibri"/>
-              </a:rPr>
-              <a:t>Concepto, término principal, sinónimos y traducción.</a:t>
-            </a:r>
-          </a:p>
-        </p:txBody>
-      </p:sp>
-      <p:sp>
-        <p:nvSpPr>
-          <p:cNvPr id="11" name="Rounded Rectangle 10"/>
-          <p:cNvSpPr/>
-          <p:nvPr/>
-        </p:nvSpPr>
-        <p:spPr>
-          <a:xfrm>
-            <a:off x="4331208" y="3977639"/>
-            <a:ext cx="3535680" cy="1508760"/>
-          </a:xfrm>
-          <a:prstGeom prst="roundRect">
-            <a:avLst>
-              <a:gd name="adj" fmla="val 6000"/>
-            </a:avLst>
-          </a:prstGeom>
-          <a:solidFill>
-            <a:srgbClr val="D9DEEF"/>
-          </a:solidFill>
-          <a:ln>
-            <a:noFill/>
-          </a:ln>
-          <a:effectLst/>
-        </p:spPr>
-        <p:style>
-          <a:lnRef idx="1">
-            <a:schemeClr val="accent1"/>
-          </a:lnRef>
-          <a:fillRef idx="3">
-            <a:schemeClr val="accent1"/>
-          </a:fillRef>
-          <a:effectRef idx="2">
-            <a:schemeClr val="accent1"/>
-          </a:effectRef>
-          <a:fontRef idx="minor">
-            <a:schemeClr val="lt1"/>
-          </a:fontRef>
-        </p:style>
-        <p:txBody>
-          <a:bodyPr rtlCol="0" anchor="ctr"/>
-          <a:lstStyle/>
-          <a:p>
-            <a:pPr algn="ctr"/>
-          </a:p>
-        </p:txBody>
-      </p:sp>
-      <p:sp>
-        <p:nvSpPr>
-          <p:cNvPr id="12" name="TextBox 11"/>
-          <p:cNvSpPr txBox="1"/>
-          <p:nvPr/>
-        </p:nvSpPr>
-        <p:spPr>
-          <a:xfrm>
-            <a:off x="4514088" y="4087368"/>
-            <a:ext cx="3169920" cy="1289304"/>
-          </a:xfrm>
-          <a:prstGeom prst="rect">
-            <a:avLst/>
-          </a:prstGeom>
-          <a:noFill/>
-        </p:spPr>
-        <p:txBody>
-          <a:bodyPr wrap="square" lIns="45720" rIns="45720" tIns="27432" bIns="27432" anchor="t">
-            <a:spAutoFit/>
-          </a:bodyPr>
-          <a:lstStyle/>
-          <a:p>
-            <a:pPr algn="l">
-              <a:spcAft>
-                <a:spcPts val="600"/>
-              </a:spcAft>
-            </a:pPr>
-            <a:r>
-              <a:rPr sz="2000" b="1" i="0">
-                <a:solidFill>
-                  <a:srgbClr val="2B4EB4"/>
-                </a:solidFill>
-                <a:latin typeface="Calibri"/>
-              </a:rPr>
-              <a:t>2. Consulta a la IA</a:t>
-            </a:r>
-          </a:p>
-          <a:p>
-            <a:pPr algn="l">
-              <a:spcAft>
-                <a:spcPts val="400"/>
-              </a:spcAft>
-            </a:pPr>
-            <a:r>
-              <a:rPr sz="1800" b="0" i="0">
-                <a:solidFill>
-                  <a:srgbClr val="011754"/>
-                </a:solidFill>
-                <a:latin typeface="Calibri"/>
-              </a:rPr>
-              <a:t>Solo después, para expandir lo que ya trabajaste.</a:t>
-            </a:r>
-          </a:p>
-        </p:txBody>
-      </p:sp>
-      <p:sp>
-        <p:nvSpPr>
-          <p:cNvPr id="13" name="Rounded Rectangle 12"/>
-          <p:cNvSpPr/>
-          <p:nvPr/>
-        </p:nvSpPr>
-        <p:spPr>
-          <a:xfrm>
-            <a:off x="8049767" y="3977639"/>
-            <a:ext cx="3535680" cy="1508760"/>
-          </a:xfrm>
-          <a:prstGeom prst="roundRect">
-            <a:avLst>
-              <a:gd name="adj" fmla="val 6000"/>
-            </a:avLst>
-          </a:prstGeom>
-          <a:solidFill>
-            <a:srgbClr val="D9DEEF"/>
-          </a:solidFill>
-          <a:ln>
-            <a:noFill/>
-          </a:ln>
-          <a:effectLst/>
-        </p:spPr>
-        <p:style>
-          <a:lnRef idx="1">
-            <a:schemeClr val="accent1"/>
-          </a:lnRef>
-          <a:fillRef idx="3">
-            <a:schemeClr val="accent1"/>
-          </a:fillRef>
-          <a:effectRef idx="2">
-            <a:schemeClr val="accent1"/>
-          </a:effectRef>
-          <a:fontRef idx="minor">
-            <a:schemeClr val="lt1"/>
-          </a:fontRef>
-        </p:style>
-        <p:txBody>
-          <a:bodyPr rtlCol="0" anchor="ctr"/>
-          <a:lstStyle/>
-          <a:p>
-            <a:pPr algn="ctr"/>
-          </a:p>
-        </p:txBody>
-      </p:sp>
-      <p:sp>
-        <p:nvSpPr>
-          <p:cNvPr id="14" name="TextBox 13"/>
-          <p:cNvSpPr txBox="1"/>
-          <p:nvPr/>
-        </p:nvSpPr>
-        <p:spPr>
-          <a:xfrm>
-            <a:off x="8232647" y="4087368"/>
-            <a:ext cx="3169920" cy="1289304"/>
-          </a:xfrm>
-          <a:prstGeom prst="rect">
-            <a:avLst/>
-          </a:prstGeom>
-          <a:noFill/>
-        </p:spPr>
-        <p:txBody>
-          <a:bodyPr wrap="square" lIns="45720" rIns="45720" tIns="27432" bIns="27432" anchor="t">
-            <a:spAutoFit/>
-          </a:bodyPr>
-          <a:lstStyle/>
-          <a:p>
-            <a:pPr algn="l">
-              <a:spcAft>
-                <a:spcPts val="600"/>
-              </a:spcAft>
-            </a:pPr>
-            <a:r>
-              <a:rPr sz="2000" b="1" i="0">
-                <a:solidFill>
-                  <a:srgbClr val="2B4EB4"/>
-                </a:solidFill>
-                <a:latin typeface="Calibri"/>
-              </a:rPr>
-              <a:t>3. Compara</a:t>
-            </a:r>
-          </a:p>
-          <a:p>
-            <a:pPr algn="l">
-              <a:spcAft>
-                <a:spcPts val="400"/>
-              </a:spcAft>
-            </a:pPr>
-            <a:r>
-              <a:rPr sz="1800" b="0" i="0">
-                <a:solidFill>
-                  <a:srgbClr val="011754"/>
-                </a:solidFill>
-                <a:latin typeface="Calibri"/>
-              </a:rPr>
-              <a:t>Marca qué aportó la IA que tú no habías considerado.</a:t>
-            </a:r>
-          </a:p>
-        </p:txBody>
-      </p:sp>
-      <p:sp>
-        <p:nvSpPr>
-          <p:cNvPr id="15" name="Rounded Rectangle 14"/>
-          <p:cNvSpPr/>
-          <p:nvPr/>
-        </p:nvSpPr>
-        <p:spPr>
-          <a:xfrm>
-            <a:off x="612648" y="5623560"/>
-            <a:ext cx="10972800" cy="594360"/>
-          </a:xfrm>
-          <a:prstGeom prst="roundRect">
-            <a:avLst>
-              <a:gd name="adj" fmla="val 6000"/>
-            </a:avLst>
-          </a:prstGeom>
-          <a:solidFill>
-            <a:srgbClr val="011754"/>
-          </a:solidFill>
-          <a:ln>
-            <a:noFill/>
-          </a:ln>
-          <a:effectLst/>
-        </p:spPr>
-        <p:style>
-          <a:lnRef idx="1">
-            <a:schemeClr val="accent1"/>
-          </a:lnRef>
-          <a:fillRef idx="3">
-            <a:schemeClr val="accent1"/>
-          </a:fillRef>
-          <a:effectRef idx="2">
-            <a:schemeClr val="accent1"/>
-          </a:effectRef>
-          <a:fontRef idx="minor">
-            <a:schemeClr val="lt1"/>
-          </a:fontRef>
-        </p:style>
-        <p:txBody>
-          <a:bodyPr rtlCol="0" anchor="ctr"/>
-          <a:lstStyle/>
-          <a:p>
-            <a:pPr algn="ctr"/>
-          </a:p>
-        </p:txBody>
-      </p:sp>
-      <p:sp>
-        <p:nvSpPr>
-          <p:cNvPr id="16" name="TextBox 15"/>
-          <p:cNvSpPr txBox="1"/>
-          <p:nvPr/>
-        </p:nvSpPr>
-        <p:spPr>
-          <a:xfrm>
-            <a:off x="841248" y="5623560"/>
-            <a:ext cx="10515600" cy="594360"/>
-          </a:xfrm>
-          <a:prstGeom prst="rect">
-            <a:avLst/>
-          </a:prstGeom>
-          <a:noFill/>
-        </p:spPr>
-        <p:txBody>
-          <a:bodyPr wrap="square" lIns="45720" rIns="45720" tIns="27432" bIns="27432" anchor="ctr">
-            <a:spAutoFit/>
-          </a:bodyPr>
-          <a:lstStyle/>
-          <a:p>
-            <a:pPr algn="l">
-              <a:spcAft>
-                <a:spcPts val="400"/>
-              </a:spcAft>
-            </a:pPr>
-            <a:r>
-              <a:rPr sz="1800" b="1" i="0">
-                <a:solidFill>
-                  <a:srgbClr val="FFFFFF"/>
-                </a:solidFill>
-                <a:latin typeface="Calibri"/>
-              </a:rPr>
-              <a:t>Regla metodológica: la IA amplía tu vocabulario; no lo reemplaza.</a:t>
-            </a:r>
-          </a:p>
-        </p:txBody>
-      </p:sp>
-    </p:spTree>
-  </p:cSld>
-  <p:clrMapOvr>
-    <a:masterClrMapping/>
-  </p:clrMapOvr>
-</p:sld>
-</file>
-
 <file path=ppt/slides/slide39.xml><?xml version="1.0" encoding="utf-8"?>
 <p:sld xmlns:a="http://schemas.openxmlformats.org/drawingml/2006/main" xmlns:p="http://schemas.openxmlformats.org/presentationml/2006/main" xmlns:r="http://schemas.openxmlformats.org/officeDocument/2006/relationships">
   <p:cSld>
@@ -13302,7 +11270,7 @@
                 </a:solidFill>
                 <a:latin typeface="Calibri"/>
               </a:rPr>
-              <a:t>Cada término que descartas, con su razón, también va a la bitácora.</a:t>
+              <a:t>Primero tus términos, después la IA; cada descarte, con su razón, va a la bitácora.</a:t>
             </a:r>
           </a:p>
         </p:txBody>
@@ -17591,576 +15559,6 @@
 </p:sld>
 </file>
 
-<file path=ppt/slides/slide44.xml><?xml version="1.0" encoding="utf-8"?>
-<p:sld xmlns:a="http://schemas.openxmlformats.org/drawingml/2006/main" xmlns:p="http://schemas.openxmlformats.org/presentationml/2006/main" xmlns:r="http://schemas.openxmlformats.org/officeDocument/2006/relationships">
-  <p:cSld>
-    <p:spTree>
-      <p:nvGrpSpPr>
-        <p:cNvPr id="1" name=""/>
-        <p:cNvGrpSpPr/>
-        <p:nvPr/>
-      </p:nvGrpSpPr>
-      <p:grpSpPr/>
-      <p:pic>
-        <p:nvPicPr>
-          <p:cNvPr id="2" name="Picture 1" descr="image.png"/>
-          <p:cNvPicPr>
-            <a:picLocks noChangeAspect="1"/>
-          </p:cNvPicPr>
-          <p:nvPr/>
-        </p:nvPicPr>
-        <p:blipFill>
-          <a:blip r:embed="rId2"/>
-          <a:stretch>
-            <a:fillRect/>
-          </a:stretch>
-        </p:blipFill>
-        <p:spPr>
-          <a:xfrm>
-            <a:off x="0" y="0"/>
-            <a:ext cx="12192000" cy="6858000"/>
-          </a:xfrm>
-          <a:prstGeom prst="rect">
-            <a:avLst/>
-          </a:prstGeom>
-        </p:spPr>
-      </p:pic>
-      <p:sp>
-        <p:nvSpPr>
-          <p:cNvPr id="3" name="TextBox 2"/>
-          <p:cNvSpPr txBox="1"/>
-          <p:nvPr/>
-        </p:nvSpPr>
-        <p:spPr>
-          <a:xfrm>
-            <a:off x="612648" y="777240"/>
-            <a:ext cx="10332720" cy="640080"/>
-          </a:xfrm>
-          <a:prstGeom prst="rect">
-            <a:avLst/>
-          </a:prstGeom>
-          <a:noFill/>
-        </p:spPr>
-        <p:txBody>
-          <a:bodyPr wrap="square" lIns="45720" rIns="45720" tIns="27432" bIns="27432" anchor="ctr">
-            <a:spAutoFit/>
-          </a:bodyPr>
-          <a:lstStyle/>
-          <a:p>
-            <a:pPr algn="l">
-              <a:spcAft>
-                <a:spcPts val="400"/>
-              </a:spcAft>
-            </a:pPr>
-            <a:r>
-              <a:rPr sz="2800" b="1" i="0">
-                <a:solidFill>
-                  <a:srgbClr val="1836B2"/>
-                </a:solidFill>
-                <a:latin typeface="Calibri"/>
-              </a:rPr>
-              <a:t>Errores frecuentes al construir cadenas</a:t>
-            </a:r>
-          </a:p>
-        </p:txBody>
-      </p:sp>
-      <p:sp>
-        <p:nvSpPr>
-          <p:cNvPr id="4" name="Rounded Rectangle 3"/>
-          <p:cNvSpPr/>
-          <p:nvPr/>
-        </p:nvSpPr>
-        <p:spPr>
-          <a:xfrm>
-            <a:off x="612648" y="1600200"/>
-            <a:ext cx="5394960" cy="1965960"/>
-          </a:xfrm>
-          <a:prstGeom prst="roundRect">
-            <a:avLst>
-              <a:gd name="adj" fmla="val 6000"/>
-            </a:avLst>
-          </a:prstGeom>
-          <a:solidFill>
-            <a:srgbClr val="F6ECC8"/>
-          </a:solidFill>
-          <a:ln>
-            <a:noFill/>
-          </a:ln>
-          <a:effectLst/>
-        </p:spPr>
-        <p:style>
-          <a:lnRef idx="1">
-            <a:schemeClr val="accent1"/>
-          </a:lnRef>
-          <a:fillRef idx="3">
-            <a:schemeClr val="accent1"/>
-          </a:fillRef>
-          <a:effectRef idx="2">
-            <a:schemeClr val="accent1"/>
-          </a:effectRef>
-          <a:fontRef idx="minor">
-            <a:schemeClr val="lt1"/>
-          </a:fontRef>
-        </p:style>
-        <p:txBody>
-          <a:bodyPr rtlCol="0" anchor="ctr"/>
-          <a:lstStyle/>
-          <a:p>
-            <a:pPr algn="ctr"/>
-          </a:p>
-        </p:txBody>
-      </p:sp>
-      <p:sp>
-        <p:nvSpPr>
-          <p:cNvPr id="5" name="TextBox 4"/>
-          <p:cNvSpPr txBox="1"/>
-          <p:nvPr/>
-        </p:nvSpPr>
-        <p:spPr>
-          <a:xfrm>
-            <a:off x="795528" y="1709928"/>
-            <a:ext cx="5029200" cy="1746504"/>
-          </a:xfrm>
-          <a:prstGeom prst="rect">
-            <a:avLst/>
-          </a:prstGeom>
-          <a:noFill/>
-        </p:spPr>
-        <p:txBody>
-          <a:bodyPr wrap="square" lIns="45720" rIns="45720" tIns="27432" bIns="27432" anchor="t">
-            <a:spAutoFit/>
-          </a:bodyPr>
-          <a:lstStyle/>
-          <a:p>
-            <a:pPr algn="l">
-              <a:spcAft>
-                <a:spcPts val="600"/>
-              </a:spcAft>
-            </a:pPr>
-            <a:r>
-              <a:rPr sz="2000" b="1" i="0">
-                <a:solidFill>
-                  <a:srgbClr val="8A5A00"/>
-                </a:solidFill>
-                <a:latin typeface="Calibri"/>
-              </a:rPr>
-              <a:t>OR en minúscula</a:t>
-            </a:r>
-          </a:p>
-          <a:p>
-            <a:pPr algn="l">
-              <a:spcAft>
-                <a:spcPts val="400"/>
-              </a:spcAft>
-            </a:pPr>
-            <a:r>
-              <a:rPr sz="1800" b="0" i="0">
-                <a:solidFill>
-                  <a:srgbClr val="011754"/>
-                </a:solidFill>
-                <a:latin typeface="Calibri"/>
-              </a:rPr>
-              <a:t>Scholar lo trata como una palabra más. Escribe siempre OR en mayúsculas.</a:t>
-            </a:r>
-          </a:p>
-        </p:txBody>
-      </p:sp>
-      <p:sp>
-        <p:nvSpPr>
-          <p:cNvPr id="6" name="Rounded Rectangle 5"/>
-          <p:cNvSpPr/>
-          <p:nvPr/>
-        </p:nvSpPr>
-        <p:spPr>
-          <a:xfrm>
-            <a:off x="6190488" y="1600200"/>
-            <a:ext cx="5394960" cy="1965960"/>
-          </a:xfrm>
-          <a:prstGeom prst="roundRect">
-            <a:avLst>
-              <a:gd name="adj" fmla="val 6000"/>
-            </a:avLst>
-          </a:prstGeom>
-          <a:solidFill>
-            <a:srgbClr val="F6ECC8"/>
-          </a:solidFill>
-          <a:ln>
-            <a:noFill/>
-          </a:ln>
-          <a:effectLst/>
-        </p:spPr>
-        <p:style>
-          <a:lnRef idx="1">
-            <a:schemeClr val="accent1"/>
-          </a:lnRef>
-          <a:fillRef idx="3">
-            <a:schemeClr val="accent1"/>
-          </a:fillRef>
-          <a:effectRef idx="2">
-            <a:schemeClr val="accent1"/>
-          </a:effectRef>
-          <a:fontRef idx="minor">
-            <a:schemeClr val="lt1"/>
-          </a:fontRef>
-        </p:style>
-        <p:txBody>
-          <a:bodyPr rtlCol="0" anchor="ctr"/>
-          <a:lstStyle/>
-          <a:p>
-            <a:pPr algn="ctr"/>
-          </a:p>
-        </p:txBody>
-      </p:sp>
-      <p:sp>
-        <p:nvSpPr>
-          <p:cNvPr id="7" name="TextBox 6"/>
-          <p:cNvSpPr txBox="1"/>
-          <p:nvPr/>
-        </p:nvSpPr>
-        <p:spPr>
-          <a:xfrm>
-            <a:off x="6373368" y="1709928"/>
-            <a:ext cx="5029200" cy="1746504"/>
-          </a:xfrm>
-          <a:prstGeom prst="rect">
-            <a:avLst/>
-          </a:prstGeom>
-          <a:noFill/>
-        </p:spPr>
-        <p:txBody>
-          <a:bodyPr wrap="square" lIns="45720" rIns="45720" tIns="27432" bIns="27432" anchor="t">
-            <a:spAutoFit/>
-          </a:bodyPr>
-          <a:lstStyle/>
-          <a:p>
-            <a:pPr algn="l">
-              <a:spcAft>
-                <a:spcPts val="600"/>
-              </a:spcAft>
-            </a:pPr>
-            <a:r>
-              <a:rPr sz="2000" b="1" i="0">
-                <a:solidFill>
-                  <a:srgbClr val="8A5A00"/>
-                </a:solidFill>
-                <a:latin typeface="Calibri"/>
-              </a:rPr>
-              <a:t>Comillas sin criterio</a:t>
-            </a:r>
-          </a:p>
-          <a:p>
-            <a:pPr algn="l">
-              <a:spcAft>
-                <a:spcPts val="400"/>
-              </a:spcAft>
-            </a:pPr>
-            <a:r>
-              <a:rPr sz="1800" b="0" i="0">
-                <a:solidFill>
-                  <a:srgbClr val="011754"/>
-                </a:solidFill>
-                <a:latin typeface="Calibri"/>
-              </a:rPr>
-              <a:t>Entre comillas, la frase debe aparecer idéntica; si es muy larga, casi no recupera nada.</a:t>
-            </a:r>
-          </a:p>
-        </p:txBody>
-      </p:sp>
-      <p:sp>
-        <p:nvSpPr>
-          <p:cNvPr id="8" name="Rounded Rectangle 7"/>
-          <p:cNvSpPr/>
-          <p:nvPr/>
-        </p:nvSpPr>
-        <p:spPr>
-          <a:xfrm>
-            <a:off x="612648" y="3749039"/>
-            <a:ext cx="5394960" cy="1965960"/>
-          </a:xfrm>
-          <a:prstGeom prst="roundRect">
-            <a:avLst>
-              <a:gd name="adj" fmla="val 6000"/>
-            </a:avLst>
-          </a:prstGeom>
-          <a:solidFill>
-            <a:srgbClr val="F6ECC8"/>
-          </a:solidFill>
-          <a:ln>
-            <a:noFill/>
-          </a:ln>
-          <a:effectLst/>
-        </p:spPr>
-        <p:style>
-          <a:lnRef idx="1">
-            <a:schemeClr val="accent1"/>
-          </a:lnRef>
-          <a:fillRef idx="3">
-            <a:schemeClr val="accent1"/>
-          </a:fillRef>
-          <a:effectRef idx="2">
-            <a:schemeClr val="accent1"/>
-          </a:effectRef>
-          <a:fontRef idx="minor">
-            <a:schemeClr val="lt1"/>
-          </a:fontRef>
-        </p:style>
-        <p:txBody>
-          <a:bodyPr rtlCol="0" anchor="ctr"/>
-          <a:lstStyle/>
-          <a:p>
-            <a:pPr algn="ctr"/>
-          </a:p>
-        </p:txBody>
-      </p:sp>
-      <p:sp>
-        <p:nvSpPr>
-          <p:cNvPr id="9" name="TextBox 8"/>
-          <p:cNvSpPr txBox="1"/>
-          <p:nvPr/>
-        </p:nvSpPr>
-        <p:spPr>
-          <a:xfrm>
-            <a:off x="795528" y="3858768"/>
-            <a:ext cx="5029200" cy="1746504"/>
-          </a:xfrm>
-          <a:prstGeom prst="rect">
-            <a:avLst/>
-          </a:prstGeom>
-          <a:noFill/>
-        </p:spPr>
-        <p:txBody>
-          <a:bodyPr wrap="square" lIns="45720" rIns="45720" tIns="27432" bIns="27432" anchor="t">
-            <a:spAutoFit/>
-          </a:bodyPr>
-          <a:lstStyle/>
-          <a:p>
-            <a:pPr algn="l">
-              <a:spcAft>
-                <a:spcPts val="600"/>
-              </a:spcAft>
-            </a:pPr>
-            <a:r>
-              <a:rPr sz="2000" b="1" i="0">
-                <a:solidFill>
-                  <a:srgbClr val="8A5A00"/>
-                </a:solidFill>
-                <a:latin typeface="Calibri"/>
-              </a:rPr>
-              <a:t>Un solo idioma</a:t>
-            </a:r>
-          </a:p>
-          <a:p>
-            <a:pPr algn="l">
-              <a:spcAft>
-                <a:spcPts val="400"/>
-              </a:spcAft>
-            </a:pPr>
-            <a:r>
-              <a:rPr sz="1800" b="0" i="0">
-                <a:solidFill>
-                  <a:srgbClr val="011754"/>
-                </a:solidFill>
-                <a:latin typeface="Calibri"/>
-              </a:rPr>
-              <a:t>Buscar solo en español omite gran parte de la literatura indexada.</a:t>
-            </a:r>
-          </a:p>
-        </p:txBody>
-      </p:sp>
-      <p:sp>
-        <p:nvSpPr>
-          <p:cNvPr id="10" name="Rounded Rectangle 9"/>
-          <p:cNvSpPr/>
-          <p:nvPr/>
-        </p:nvSpPr>
-        <p:spPr>
-          <a:xfrm>
-            <a:off x="6190488" y="3749039"/>
-            <a:ext cx="5394960" cy="1965960"/>
-          </a:xfrm>
-          <a:prstGeom prst="roundRect">
-            <a:avLst>
-              <a:gd name="adj" fmla="val 6000"/>
-            </a:avLst>
-          </a:prstGeom>
-          <a:solidFill>
-            <a:srgbClr val="F6ECC8"/>
-          </a:solidFill>
-          <a:ln>
-            <a:noFill/>
-          </a:ln>
-          <a:effectLst/>
-        </p:spPr>
-        <p:style>
-          <a:lnRef idx="1">
-            <a:schemeClr val="accent1"/>
-          </a:lnRef>
-          <a:fillRef idx="3">
-            <a:schemeClr val="accent1"/>
-          </a:fillRef>
-          <a:effectRef idx="2">
-            <a:schemeClr val="accent1"/>
-          </a:effectRef>
-          <a:fontRef idx="minor">
-            <a:schemeClr val="lt1"/>
-          </a:fontRef>
-        </p:style>
-        <p:txBody>
-          <a:bodyPr rtlCol="0" anchor="ctr"/>
-          <a:lstStyle/>
-          <a:p>
-            <a:pPr algn="ctr"/>
-          </a:p>
-        </p:txBody>
-      </p:sp>
-      <p:sp>
-        <p:nvSpPr>
-          <p:cNvPr id="11" name="TextBox 10"/>
-          <p:cNvSpPr txBox="1"/>
-          <p:nvPr/>
-        </p:nvSpPr>
-        <p:spPr>
-          <a:xfrm>
-            <a:off x="6373368" y="3858768"/>
-            <a:ext cx="5029200" cy="1746504"/>
-          </a:xfrm>
-          <a:prstGeom prst="rect">
-            <a:avLst/>
-          </a:prstGeom>
-          <a:noFill/>
-        </p:spPr>
-        <p:txBody>
-          <a:bodyPr wrap="square" lIns="45720" rIns="45720" tIns="27432" bIns="27432" anchor="t">
-            <a:spAutoFit/>
-          </a:bodyPr>
-          <a:lstStyle/>
-          <a:p>
-            <a:pPr algn="l">
-              <a:spcAft>
-                <a:spcPts val="600"/>
-              </a:spcAft>
-            </a:pPr>
-            <a:r>
-              <a:rPr sz="2000" b="1" i="0">
-                <a:solidFill>
-                  <a:srgbClr val="8A5A00"/>
-                </a:solidFill>
-                <a:latin typeface="Calibri"/>
-              </a:rPr>
-              <a:t>No registrar</a:t>
-            </a:r>
-          </a:p>
-          <a:p>
-            <a:pPr algn="l">
-              <a:spcAft>
-                <a:spcPts val="400"/>
-              </a:spcAft>
-            </a:pPr>
-            <a:r>
-              <a:rPr sz="1800" b="0" i="0">
-                <a:solidFill>
-                  <a:srgbClr val="011754"/>
-                </a:solidFill>
-                <a:latin typeface="Calibri"/>
-              </a:rPr>
-              <a:t>Una búsqueda sin cadena, fecha y filtros anotados no se puede repetir.</a:t>
-            </a:r>
-          </a:p>
-        </p:txBody>
-      </p:sp>
-      <p:sp>
-        <p:nvSpPr>
-          <p:cNvPr id="12" name="Rounded Rectangle 11"/>
-          <p:cNvSpPr/>
-          <p:nvPr/>
-        </p:nvSpPr>
-        <p:spPr>
-          <a:xfrm>
-            <a:off x="612648" y="5486400"/>
-            <a:ext cx="10972800" cy="640080"/>
-          </a:xfrm>
-          <a:prstGeom prst="roundRect">
-            <a:avLst>
-              <a:gd name="adj" fmla="val 6000"/>
-            </a:avLst>
-          </a:prstGeom>
-          <a:solidFill>
-            <a:srgbClr val="011754"/>
-          </a:solidFill>
-          <a:ln>
-            <a:noFill/>
-          </a:ln>
-          <a:effectLst/>
-        </p:spPr>
-        <p:style>
-          <a:lnRef idx="1">
-            <a:schemeClr val="accent1"/>
-          </a:lnRef>
-          <a:fillRef idx="3">
-            <a:schemeClr val="accent1"/>
-          </a:fillRef>
-          <a:effectRef idx="2">
-            <a:schemeClr val="accent1"/>
-          </a:effectRef>
-          <a:fontRef idx="minor">
-            <a:schemeClr val="lt1"/>
-          </a:fontRef>
-        </p:style>
-        <p:txBody>
-          <a:bodyPr rtlCol="0" anchor="ctr"/>
-          <a:lstStyle/>
-          <a:p>
-            <a:pPr algn="ctr"/>
-          </a:p>
-        </p:txBody>
-      </p:sp>
-      <p:sp>
-        <p:nvSpPr>
-          <p:cNvPr id="13" name="TextBox 12"/>
-          <p:cNvSpPr txBox="1"/>
-          <p:nvPr/>
-        </p:nvSpPr>
-        <p:spPr>
-          <a:xfrm>
-            <a:off x="841248" y="5486400"/>
-            <a:ext cx="10515600" cy="640080"/>
-          </a:xfrm>
-          <a:prstGeom prst="rect">
-            <a:avLst/>
-          </a:prstGeom>
-          <a:noFill/>
-        </p:spPr>
-        <p:txBody>
-          <a:bodyPr wrap="square" lIns="45720" rIns="45720" tIns="27432" bIns="27432" anchor="ctr">
-            <a:spAutoFit/>
-          </a:bodyPr>
-          <a:lstStyle/>
-          <a:p>
-            <a:pPr algn="l">
-              <a:spcAft>
-                <a:spcPts val="400"/>
-              </a:spcAft>
-            </a:pPr>
-            <a:r>
-              <a:rPr sz="1800" b="1" i="0">
-                <a:solidFill>
-                  <a:srgbClr val="FFFFFF"/>
-                </a:solidFill>
-                <a:latin typeface="Calibri"/>
-              </a:rPr>
-              <a:t>Prueba, observa cuántos resultados salen y ajusta: buscar es un proceso iterativo.</a:t>
-            </a:r>
-          </a:p>
-        </p:txBody>
-      </p:sp>
-    </p:spTree>
-  </p:cSld>
-  <p:clrMapOvr>
-    <a:masterClrMapping/>
-  </p:clrMapOvr>
-</p:sld>
-</file>
-
 <file path=ppt/slides/slide45.xml><?xml version="1.0" encoding="utf-8"?>
 <p:sld xmlns:a="http://schemas.openxmlformats.org/drawingml/2006/main" xmlns:p="http://schemas.openxmlformats.org/presentationml/2006/main" xmlns:r="http://schemas.openxmlformats.org/officeDocument/2006/relationships">
   <p:cSld>
@@ -18718,1009 +16116,7 @@
                 </a:solidFill>
                 <a:latin typeface="Calibri"/>
               </a:rPr>
-              <a:t>Google Scholar recupera fuentes; la IA amplía el vocabulario; la bitácora deja constancia.</a:t>
-            </a:r>
-          </a:p>
-        </p:txBody>
-      </p:sp>
-    </p:spTree>
-  </p:cSld>
-  <p:clrMapOvr>
-    <a:masterClrMapping/>
-  </p:clrMapOvr>
-</p:sld>
-</file>
-
-<file path=ppt/slides/slide46.xml><?xml version="1.0" encoding="utf-8"?>
-<p:sld xmlns:a="http://schemas.openxmlformats.org/drawingml/2006/main" xmlns:p="http://schemas.openxmlformats.org/presentationml/2006/main" xmlns:r="http://schemas.openxmlformats.org/officeDocument/2006/relationships">
-  <p:cSld>
-    <p:spTree>
-      <p:nvGrpSpPr>
-        <p:cNvPr id="1" name=""/>
-        <p:cNvGrpSpPr/>
-        <p:nvPr/>
-      </p:nvGrpSpPr>
-      <p:grpSpPr/>
-      <p:pic>
-        <p:nvPicPr>
-          <p:cNvPr id="2" name="Picture 1" descr="image.png"/>
-          <p:cNvPicPr>
-            <a:picLocks noChangeAspect="1"/>
-          </p:cNvPicPr>
-          <p:nvPr/>
-        </p:nvPicPr>
-        <p:blipFill>
-          <a:blip r:embed="rId2"/>
-          <a:stretch>
-            <a:fillRect/>
-          </a:stretch>
-        </p:blipFill>
-        <p:spPr>
-          <a:xfrm>
-            <a:off x="0" y="0"/>
-            <a:ext cx="12192000" cy="6858000"/>
-          </a:xfrm>
-          <a:prstGeom prst="rect">
-            <a:avLst/>
-          </a:prstGeom>
-        </p:spPr>
-      </p:pic>
-      <p:sp>
-        <p:nvSpPr>
-          <p:cNvPr id="3" name="TextBox 2"/>
-          <p:cNvSpPr txBox="1"/>
-          <p:nvPr/>
-        </p:nvSpPr>
-        <p:spPr>
-          <a:xfrm>
-            <a:off x="612648" y="777240"/>
-            <a:ext cx="10332720" cy="640080"/>
-          </a:xfrm>
-          <a:prstGeom prst="rect">
-            <a:avLst/>
-          </a:prstGeom>
-          <a:noFill/>
-        </p:spPr>
-        <p:txBody>
-          <a:bodyPr wrap="square" lIns="45720" rIns="45720" tIns="27432" bIns="27432" anchor="ctr">
-            <a:spAutoFit/>
-          </a:bodyPr>
-          <a:lstStyle/>
-          <a:p>
-            <a:pPr algn="l">
-              <a:spcAft>
-                <a:spcPts val="400"/>
-              </a:spcAft>
-            </a:pPr>
-            <a:r>
-              <a:rPr sz="2800" b="1" i="0">
-                <a:solidFill>
-                  <a:srgbClr val="1836B2"/>
-                </a:solidFill>
-                <a:latin typeface="Calibri"/>
-              </a:rPr>
-              <a:t>Explorar no es validar</a:t>
-            </a:r>
-          </a:p>
-        </p:txBody>
-      </p:sp>
-      <p:graphicFrame>
-        <p:nvGraphicFramePr>
-          <p:cNvPr id="4" name="Table 3"/>
-          <p:cNvGraphicFramePr>
-            <a:graphicFrameLocks noGrp="1"/>
-          </p:cNvGraphicFramePr>
-          <p:nvPr/>
-        </p:nvGraphicFramePr>
-        <p:xfrm>
-          <a:off x="612648" y="1600200"/>
-          <a:ext cx="10972800" cy="3182112"/>
-        </p:xfrm>
-        <a:graphic>
-          <a:graphicData uri="http://schemas.openxmlformats.org/drawingml/2006/table">
-            <a:tbl>
-              <a:tblPr firstRow="1" bandRow="1">
-                <a:tableStyleId>{5C22544A-7EE6-4342-B048-85BDC9FD1C3A}</a:tableStyleId>
-              </a:tblPr>
-              <a:tblGrid>
-                <a:gridCol w="3657600"/>
-                <a:gridCol w="7315200"/>
-              </a:tblGrid>
-              <a:tr h="548640">
-                <a:tc>
-                  <a:txBody>
-                    <a:bodyPr wrap="square"/>
-                    <a:lstStyle/>
-                    <a:p>
-                      <a:pPr algn="l"/>
-                      <a:r>
-                        <a:rPr sz="1800" b="1">
-                          <a:solidFill>
-                            <a:srgbClr val="FFFFFF"/>
-                          </a:solidFill>
-                          <a:latin typeface="Calibri"/>
-                        </a:rPr>
-                        <a:t>Entorno</a:t>
-                      </a:r>
-                    </a:p>
-                  </a:txBody>
-                  <a:tcPr anchor="ctr" marL="109728" marR="109728">
-                    <a:solidFill>
-                      <a:srgbClr val="011754"/>
-                    </a:solidFill>
-                  </a:tcPr>
-                </a:tc>
-                <a:tc>
-                  <a:txBody>
-                    <a:bodyPr wrap="square"/>
-                    <a:lstStyle/>
-                    <a:p>
-                      <a:pPr algn="l"/>
-                      <a:r>
-                        <a:rPr sz="1800" b="1">
-                          <a:solidFill>
-                            <a:srgbClr val="FFFFFF"/>
-                          </a:solidFill>
-                          <a:latin typeface="Calibri"/>
-                        </a:rPr>
-                        <a:t>Función en la búsqueda</a:t>
-                      </a:r>
-                    </a:p>
-                  </a:txBody>
-                  <a:tcPr anchor="ctr" marL="109728" marR="109728">
-                    <a:solidFill>
-                      <a:srgbClr val="011754"/>
-                    </a:solidFill>
-                  </a:tcPr>
-                </a:tc>
-              </a:tr>
-              <a:tr h="658368">
-                <a:tc>
-                  <a:txBody>
-                    <a:bodyPr wrap="square"/>
-                    <a:lstStyle/>
-                    <a:p>
-                      <a:pPr algn="l"/>
-                      <a:r>
-                        <a:rPr sz="1800" b="1">
-                          <a:solidFill>
-                            <a:srgbClr val="011754"/>
-                          </a:solidFill>
-                          <a:latin typeface="Calibri"/>
-                        </a:rPr>
-                        <a:t>Google</a:t>
-                      </a:r>
-                    </a:p>
-                  </a:txBody>
-                  <a:tcPr anchor="ctr" marL="109728" marR="109728">
-                    <a:solidFill>
-                      <a:srgbClr val="D9DEEF"/>
-                    </a:solidFill>
-                  </a:tcPr>
-                </a:tc>
-                <a:tc>
-                  <a:txBody>
-                    <a:bodyPr wrap="square"/>
-                    <a:lstStyle/>
-                    <a:p>
-                      <a:pPr algn="l"/>
-                      <a:r>
-                        <a:rPr sz="1800" b="0">
-                          <a:solidFill>
-                            <a:srgbClr val="011754"/>
-                          </a:solidFill>
-                          <a:latin typeface="Calibri"/>
-                        </a:rPr>
-                        <a:t>Web general: páginas, noticias, blogs</a:t>
-                      </a:r>
-                    </a:p>
-                  </a:txBody>
-                  <a:tcPr anchor="ctr" marL="109728" marR="109728">
-                    <a:solidFill>
-                      <a:srgbClr val="D9DEEF"/>
-                    </a:solidFill>
-                  </a:tcPr>
-                </a:tc>
-              </a:tr>
-              <a:tr h="658368">
-                <a:tc>
-                  <a:txBody>
-                    <a:bodyPr wrap="square"/>
-                    <a:lstStyle/>
-                    <a:p>
-                      <a:pPr algn="l"/>
-                      <a:r>
-                        <a:rPr sz="1800" b="1">
-                          <a:solidFill>
-                            <a:srgbClr val="011754"/>
-                          </a:solidFill>
-                          <a:latin typeface="Calibri"/>
-                        </a:rPr>
-                        <a:t>Google Scholar</a:t>
-                      </a:r>
-                    </a:p>
-                  </a:txBody>
-                  <a:tcPr anchor="ctr" marL="109728" marR="109728">
-                    <a:solidFill>
-                      <a:srgbClr val="FFFFFF"/>
-                    </a:solidFill>
-                  </a:tcPr>
-                </a:tc>
-                <a:tc>
-                  <a:txBody>
-                    <a:bodyPr wrap="square"/>
-                    <a:lstStyle/>
-                    <a:p>
-                      <a:pPr algn="l"/>
-                      <a:r>
-                        <a:rPr sz="1800" b="0">
-                          <a:solidFill>
-                            <a:srgbClr val="011754"/>
-                          </a:solidFill>
-                          <a:latin typeface="Calibri"/>
-                        </a:rPr>
-                        <a:t>Literatura académica recuperada</a:t>
-                      </a:r>
-                    </a:p>
-                  </a:txBody>
-                  <a:tcPr anchor="ctr" marL="109728" marR="109728">
-                    <a:solidFill>
-                      <a:srgbClr val="FFFFFF"/>
-                    </a:solidFill>
-                  </a:tcPr>
-                </a:tc>
-              </a:tr>
-              <a:tr h="658368">
-                <a:tc>
-                  <a:txBody>
-                    <a:bodyPr wrap="square"/>
-                    <a:lstStyle/>
-                    <a:p>
-                      <a:pPr algn="l"/>
-                      <a:r>
-                        <a:rPr sz="1800" b="1">
-                          <a:solidFill>
-                            <a:srgbClr val="011754"/>
-                          </a:solidFill>
-                          <a:latin typeface="Calibri"/>
-                        </a:rPr>
-                        <a:t>IA conversacional</a:t>
-                      </a:r>
-                    </a:p>
-                  </a:txBody>
-                  <a:tcPr anchor="ctr" marL="109728" marR="109728">
-                    <a:solidFill>
-                      <a:srgbClr val="D9DEEF"/>
-                    </a:solidFill>
-                  </a:tcPr>
-                </a:tc>
-                <a:tc>
-                  <a:txBody>
-                    <a:bodyPr wrap="square"/>
-                    <a:lstStyle/>
-                    <a:p>
-                      <a:pPr algn="l"/>
-                      <a:r>
-                        <a:rPr sz="1800" b="0">
-                          <a:solidFill>
-                            <a:srgbClr val="011754"/>
-                          </a:solidFill>
-                          <a:latin typeface="Calibri"/>
-                        </a:rPr>
-                        <a:t>Generación y exploración de ideas</a:t>
-                      </a:r>
-                    </a:p>
-                  </a:txBody>
-                  <a:tcPr anchor="ctr" marL="109728" marR="109728">
-                    <a:solidFill>
-                      <a:srgbClr val="D9DEEF"/>
-                    </a:solidFill>
-                  </a:tcPr>
-                </a:tc>
-              </a:tr>
-              <a:tr h="658368">
-                <a:tc>
-                  <a:txBody>
-                    <a:bodyPr wrap="square"/>
-                    <a:lstStyle/>
-                    <a:p>
-                      <a:pPr algn="l"/>
-                      <a:r>
-                        <a:rPr sz="1800" b="1">
-                          <a:solidFill>
-                            <a:srgbClr val="011754"/>
-                          </a:solidFill>
-                          <a:latin typeface="Calibri"/>
-                        </a:rPr>
-                        <a:t>IA para literatura</a:t>
-                      </a:r>
-                    </a:p>
-                  </a:txBody>
-                  <a:tcPr anchor="ctr" marL="109728" marR="109728">
-                    <a:solidFill>
-                      <a:srgbClr val="FFFFFF"/>
-                    </a:solidFill>
-                  </a:tcPr>
-                </a:tc>
-                <a:tc>
-                  <a:txBody>
-                    <a:bodyPr wrap="square"/>
-                    <a:lstStyle/>
-                    <a:p>
-                      <a:pPr algn="l"/>
-                      <a:r>
-                        <a:rPr sz="1800" b="0">
-                          <a:solidFill>
-                            <a:srgbClr val="011754"/>
-                          </a:solidFill>
-                          <a:latin typeface="Calibri"/>
-                        </a:rPr>
-                        <a:t>Descubrimiento y análisis asistido</a:t>
-                      </a:r>
-                    </a:p>
-                  </a:txBody>
-                  <a:tcPr anchor="ctr" marL="109728" marR="109728">
-                    <a:solidFill>
-                      <a:srgbClr val="FFFFFF"/>
-                    </a:solidFill>
-                  </a:tcPr>
-                </a:tc>
-              </a:tr>
-            </a:tbl>
-          </a:graphicData>
-        </a:graphic>
-      </p:graphicFrame>
-      <p:sp>
-        <p:nvSpPr>
-          <p:cNvPr id="5" name="Rounded Rectangle 4"/>
-          <p:cNvSpPr/>
-          <p:nvPr/>
-        </p:nvSpPr>
-        <p:spPr>
-          <a:xfrm>
-            <a:off x="612648" y="5212080"/>
-            <a:ext cx="10972800" cy="868680"/>
-          </a:xfrm>
-          <a:prstGeom prst="roundRect">
-            <a:avLst>
-              <a:gd name="adj" fmla="val 6000"/>
-            </a:avLst>
-          </a:prstGeom>
-          <a:solidFill>
-            <a:srgbClr val="011754"/>
-          </a:solidFill>
-          <a:ln>
-            <a:noFill/>
-          </a:ln>
-          <a:effectLst/>
-        </p:spPr>
-        <p:style>
-          <a:lnRef idx="1">
-            <a:schemeClr val="accent1"/>
-          </a:lnRef>
-          <a:fillRef idx="3">
-            <a:schemeClr val="accent1"/>
-          </a:fillRef>
-          <a:effectRef idx="2">
-            <a:schemeClr val="accent1"/>
-          </a:effectRef>
-          <a:fontRef idx="minor">
-            <a:schemeClr val="lt1"/>
-          </a:fontRef>
-        </p:style>
-        <p:txBody>
-          <a:bodyPr rtlCol="0" anchor="ctr"/>
-          <a:lstStyle/>
-          <a:p>
-            <a:pPr algn="ctr"/>
-          </a:p>
-        </p:txBody>
-      </p:sp>
-      <p:sp>
-        <p:nvSpPr>
-          <p:cNvPr id="6" name="TextBox 5"/>
-          <p:cNvSpPr txBox="1"/>
-          <p:nvPr/>
-        </p:nvSpPr>
-        <p:spPr>
-          <a:xfrm>
-            <a:off x="841248" y="5212080"/>
-            <a:ext cx="10515600" cy="868680"/>
-          </a:xfrm>
-          <a:prstGeom prst="rect">
-            <a:avLst/>
-          </a:prstGeom>
-          <a:noFill/>
-        </p:spPr>
-        <p:txBody>
-          <a:bodyPr wrap="square" lIns="45720" rIns="45720" tIns="27432" bIns="27432" anchor="ctr">
-            <a:spAutoFit/>
-          </a:bodyPr>
-          <a:lstStyle/>
-          <a:p>
-            <a:pPr algn="l">
-              <a:spcAft>
-                <a:spcPts val="400"/>
-              </a:spcAft>
-            </a:pPr>
-            <a:r>
-              <a:rPr sz="1800" b="1" i="0">
-                <a:solidFill>
-                  <a:srgbClr val="FFFFFF"/>
-                </a:solidFill>
-                <a:latin typeface="Calibri"/>
-              </a:rPr>
-              <a:t>Una fuente que muestra una IA no es evidencia validada: hay que encontrarla y comprobarla.</a:t>
-            </a:r>
-          </a:p>
-        </p:txBody>
-      </p:sp>
-    </p:spTree>
-  </p:cSld>
-  <p:clrMapOvr>
-    <a:masterClrMapping/>
-  </p:clrMapOvr>
-</p:sld>
-</file>
-
-<file path=ppt/slides/slide47.xml><?xml version="1.0" encoding="utf-8"?>
-<p:sld xmlns:a="http://schemas.openxmlformats.org/drawingml/2006/main" xmlns:p="http://schemas.openxmlformats.org/presentationml/2006/main" xmlns:r="http://schemas.openxmlformats.org/officeDocument/2006/relationships">
-  <p:cSld>
-    <p:spTree>
-      <p:nvGrpSpPr>
-        <p:cNvPr id="1" name=""/>
-        <p:cNvGrpSpPr/>
-        <p:nvPr/>
-      </p:nvGrpSpPr>
-      <p:grpSpPr/>
-      <p:pic>
-        <p:nvPicPr>
-          <p:cNvPr id="2" name="Picture 1" descr="image.png"/>
-          <p:cNvPicPr>
-            <a:picLocks noChangeAspect="1"/>
-          </p:cNvPicPr>
-          <p:nvPr/>
-        </p:nvPicPr>
-        <p:blipFill>
-          <a:blip r:embed="rId2"/>
-          <a:stretch>
-            <a:fillRect/>
-          </a:stretch>
-        </p:blipFill>
-        <p:spPr>
-          <a:xfrm>
-            <a:off x="0" y="0"/>
-            <a:ext cx="12192000" cy="6858000"/>
-          </a:xfrm>
-          <a:prstGeom prst="rect">
-            <a:avLst/>
-          </a:prstGeom>
-        </p:spPr>
-      </p:pic>
-      <p:sp>
-        <p:nvSpPr>
-          <p:cNvPr id="3" name="TextBox 2"/>
-          <p:cNvSpPr txBox="1"/>
-          <p:nvPr/>
-        </p:nvSpPr>
-        <p:spPr>
-          <a:xfrm>
-            <a:off x="612648" y="777240"/>
-            <a:ext cx="10332720" cy="640080"/>
-          </a:xfrm>
-          <a:prstGeom prst="rect">
-            <a:avLst/>
-          </a:prstGeom>
-          <a:noFill/>
-        </p:spPr>
-        <p:txBody>
-          <a:bodyPr wrap="square" lIns="45720" rIns="45720" tIns="27432" bIns="27432" anchor="ctr">
-            <a:spAutoFit/>
-          </a:bodyPr>
-          <a:lstStyle/>
-          <a:p>
-            <a:pPr algn="l">
-              <a:spcAft>
-                <a:spcPts val="400"/>
-              </a:spcAft>
-            </a:pPr>
-            <a:r>
-              <a:rPr sz="2800" b="1" i="0">
-                <a:solidFill>
-                  <a:srgbClr val="1836B2"/>
-                </a:solidFill>
-                <a:latin typeface="Calibri"/>
-              </a:rPr>
-              <a:t>La IA amplía el vocabulario</a:t>
-            </a:r>
-          </a:p>
-        </p:txBody>
-      </p:sp>
-      <p:sp>
-        <p:nvSpPr>
-          <p:cNvPr id="4" name="Rounded Rectangle 3"/>
-          <p:cNvSpPr/>
-          <p:nvPr/>
-        </p:nvSpPr>
-        <p:spPr>
-          <a:xfrm>
-            <a:off x="612648" y="1600200"/>
-            <a:ext cx="5394960" cy="1965960"/>
-          </a:xfrm>
-          <a:prstGeom prst="roundRect">
-            <a:avLst>
-              <a:gd name="adj" fmla="val 6000"/>
-            </a:avLst>
-          </a:prstGeom>
-          <a:solidFill>
-            <a:srgbClr val="D9DEEF"/>
-          </a:solidFill>
-          <a:ln>
-            <a:noFill/>
-          </a:ln>
-          <a:effectLst/>
-        </p:spPr>
-        <p:style>
-          <a:lnRef idx="1">
-            <a:schemeClr val="accent1"/>
-          </a:lnRef>
-          <a:fillRef idx="3">
-            <a:schemeClr val="accent1"/>
-          </a:fillRef>
-          <a:effectRef idx="2">
-            <a:schemeClr val="accent1"/>
-          </a:effectRef>
-          <a:fontRef idx="minor">
-            <a:schemeClr val="lt1"/>
-          </a:fontRef>
-        </p:style>
-        <p:txBody>
-          <a:bodyPr rtlCol="0" anchor="ctr"/>
-          <a:lstStyle/>
-          <a:p>
-            <a:pPr algn="ctr"/>
-          </a:p>
-        </p:txBody>
-      </p:sp>
-      <p:sp>
-        <p:nvSpPr>
-          <p:cNvPr id="5" name="TextBox 4"/>
-          <p:cNvSpPr txBox="1"/>
-          <p:nvPr/>
-        </p:nvSpPr>
-        <p:spPr>
-          <a:xfrm>
-            <a:off x="795528" y="1709928"/>
-            <a:ext cx="5029200" cy="1746504"/>
-          </a:xfrm>
-          <a:prstGeom prst="rect">
-            <a:avLst/>
-          </a:prstGeom>
-          <a:noFill/>
-        </p:spPr>
-        <p:txBody>
-          <a:bodyPr wrap="square" lIns="45720" rIns="45720" tIns="27432" bIns="27432" anchor="t">
-            <a:spAutoFit/>
-          </a:bodyPr>
-          <a:lstStyle/>
-          <a:p>
-            <a:pPr algn="l">
-              <a:spcAft>
-                <a:spcPts val="600"/>
-              </a:spcAft>
-            </a:pPr>
-            <a:r>
-              <a:rPr sz="2000" b="1" i="0">
-                <a:solidFill>
-                  <a:srgbClr val="2B4EB4"/>
-                </a:solidFill>
-                <a:latin typeface="Calibri"/>
-              </a:rPr>
-              <a:t>Vocabulario nuevo</a:t>
-            </a:r>
-          </a:p>
-          <a:p>
-            <a:pPr algn="l">
-              <a:spcAft>
-                <a:spcPts val="400"/>
-              </a:spcAft>
-            </a:pPr>
-            <a:r>
-              <a:rPr sz="1800" b="0" i="0">
-                <a:solidFill>
-                  <a:srgbClr val="011754"/>
-                </a:solidFill>
-                <a:latin typeface="Calibri"/>
-              </a:rPr>
-              <a:t>Detecta conceptos emergentes y palabras clave técnicas de publicaciones recientes.</a:t>
-            </a:r>
-          </a:p>
-        </p:txBody>
-      </p:sp>
-      <p:sp>
-        <p:nvSpPr>
-          <p:cNvPr id="6" name="Rounded Rectangle 5"/>
-          <p:cNvSpPr/>
-          <p:nvPr/>
-        </p:nvSpPr>
-        <p:spPr>
-          <a:xfrm>
-            <a:off x="6190488" y="1600200"/>
-            <a:ext cx="5394960" cy="1965960"/>
-          </a:xfrm>
-          <a:prstGeom prst="roundRect">
-            <a:avLst>
-              <a:gd name="adj" fmla="val 6000"/>
-            </a:avLst>
-          </a:prstGeom>
-          <a:solidFill>
-            <a:srgbClr val="D9DEEF"/>
-          </a:solidFill>
-          <a:ln>
-            <a:noFill/>
-          </a:ln>
-          <a:effectLst/>
-        </p:spPr>
-        <p:style>
-          <a:lnRef idx="1">
-            <a:schemeClr val="accent1"/>
-          </a:lnRef>
-          <a:fillRef idx="3">
-            <a:schemeClr val="accent1"/>
-          </a:fillRef>
-          <a:effectRef idx="2">
-            <a:schemeClr val="accent1"/>
-          </a:effectRef>
-          <a:fontRef idx="minor">
-            <a:schemeClr val="lt1"/>
-          </a:fontRef>
-        </p:style>
-        <p:txBody>
-          <a:bodyPr rtlCol="0" anchor="ctr"/>
-          <a:lstStyle/>
-          <a:p>
-            <a:pPr algn="ctr"/>
-          </a:p>
-        </p:txBody>
-      </p:sp>
-      <p:sp>
-        <p:nvSpPr>
-          <p:cNvPr id="7" name="TextBox 6"/>
-          <p:cNvSpPr txBox="1"/>
-          <p:nvPr/>
-        </p:nvSpPr>
-        <p:spPr>
-          <a:xfrm>
-            <a:off x="6373368" y="1709928"/>
-            <a:ext cx="5029200" cy="1746504"/>
-          </a:xfrm>
-          <a:prstGeom prst="rect">
-            <a:avLst/>
-          </a:prstGeom>
-          <a:noFill/>
-        </p:spPr>
-        <p:txBody>
-          <a:bodyPr wrap="square" lIns="45720" rIns="45720" tIns="27432" bIns="27432" anchor="t">
-            <a:spAutoFit/>
-          </a:bodyPr>
-          <a:lstStyle/>
-          <a:p>
-            <a:pPr algn="l">
-              <a:spcAft>
-                <a:spcPts val="600"/>
-              </a:spcAft>
-            </a:pPr>
-            <a:r>
-              <a:rPr sz="2000" b="1" i="0">
-                <a:solidFill>
-                  <a:srgbClr val="2B4EB4"/>
-                </a:solidFill>
-                <a:latin typeface="Calibri"/>
-              </a:rPr>
-              <a:t>Traducción académica</a:t>
-            </a:r>
-          </a:p>
-          <a:p>
-            <a:pPr algn="l">
-              <a:spcAft>
-                <a:spcPts val="400"/>
-              </a:spcAft>
-            </a:pPr>
-            <a:r>
-              <a:rPr sz="1800" b="0" i="0">
-                <a:solidFill>
-                  <a:srgbClr val="011754"/>
-                </a:solidFill>
-                <a:latin typeface="Calibri"/>
-              </a:rPr>
-              <a:t>Traduce términos al inglés conservando el sentido de la pregunta.</a:t>
-            </a:r>
-          </a:p>
-        </p:txBody>
-      </p:sp>
-      <p:sp>
-        <p:nvSpPr>
-          <p:cNvPr id="8" name="Rounded Rectangle 7"/>
-          <p:cNvSpPr/>
-          <p:nvPr/>
-        </p:nvSpPr>
-        <p:spPr>
-          <a:xfrm>
-            <a:off x="612648" y="3749039"/>
-            <a:ext cx="5394960" cy="1965960"/>
-          </a:xfrm>
-          <a:prstGeom prst="roundRect">
-            <a:avLst>
-              <a:gd name="adj" fmla="val 6000"/>
-            </a:avLst>
-          </a:prstGeom>
-          <a:solidFill>
-            <a:srgbClr val="D9DEEF"/>
-          </a:solidFill>
-          <a:ln>
-            <a:noFill/>
-          </a:ln>
-          <a:effectLst/>
-        </p:spPr>
-        <p:style>
-          <a:lnRef idx="1">
-            <a:schemeClr val="accent1"/>
-          </a:lnRef>
-          <a:fillRef idx="3">
-            <a:schemeClr val="accent1"/>
-          </a:fillRef>
-          <a:effectRef idx="2">
-            <a:schemeClr val="accent1"/>
-          </a:effectRef>
-          <a:fontRef idx="minor">
-            <a:schemeClr val="lt1"/>
-          </a:fontRef>
-        </p:style>
-        <p:txBody>
-          <a:bodyPr rtlCol="0" anchor="ctr"/>
-          <a:lstStyle/>
-          <a:p>
-            <a:pPr algn="ctr"/>
-          </a:p>
-        </p:txBody>
-      </p:sp>
-      <p:sp>
-        <p:nvSpPr>
-          <p:cNvPr id="9" name="TextBox 8"/>
-          <p:cNvSpPr txBox="1"/>
-          <p:nvPr/>
-        </p:nvSpPr>
-        <p:spPr>
-          <a:xfrm>
-            <a:off x="795528" y="3858768"/>
-            <a:ext cx="5029200" cy="1746504"/>
-          </a:xfrm>
-          <a:prstGeom prst="rect">
-            <a:avLst/>
-          </a:prstGeom>
-          <a:noFill/>
-        </p:spPr>
-        <p:txBody>
-          <a:bodyPr wrap="square" lIns="45720" rIns="45720" tIns="27432" bIns="27432" anchor="t">
-            <a:spAutoFit/>
-          </a:bodyPr>
-          <a:lstStyle/>
-          <a:p>
-            <a:pPr algn="l">
-              <a:spcAft>
-                <a:spcPts val="600"/>
-              </a:spcAft>
-            </a:pPr>
-            <a:r>
-              <a:rPr sz="2000" b="1" i="0">
-                <a:solidFill>
-                  <a:srgbClr val="2B4EB4"/>
-                </a:solidFill>
-                <a:latin typeface="Calibri"/>
-              </a:rPr>
-              <a:t>Cadenas alternativas</a:t>
-            </a:r>
-          </a:p>
-          <a:p>
-            <a:pPr algn="l">
-              <a:spcAft>
-                <a:spcPts val="400"/>
-              </a:spcAft>
-            </a:pPr>
-            <a:r>
-              <a:rPr sz="1800" b="0" i="0">
-                <a:solidFill>
-                  <a:srgbClr val="011754"/>
-                </a:solidFill>
-                <a:latin typeface="Calibri"/>
-              </a:rPr>
-              <a:t>Propone combinaciones con comillas, AND y OR para probar.</a:t>
-            </a:r>
-          </a:p>
-        </p:txBody>
-      </p:sp>
-      <p:sp>
-        <p:nvSpPr>
-          <p:cNvPr id="10" name="Rounded Rectangle 9"/>
-          <p:cNvSpPr/>
-          <p:nvPr/>
-        </p:nvSpPr>
-        <p:spPr>
-          <a:xfrm>
-            <a:off x="6190488" y="3749039"/>
-            <a:ext cx="5394960" cy="1965960"/>
-          </a:xfrm>
-          <a:prstGeom prst="roundRect">
-            <a:avLst>
-              <a:gd name="adj" fmla="val 6000"/>
-            </a:avLst>
-          </a:prstGeom>
-          <a:solidFill>
-            <a:srgbClr val="D9DEEF"/>
-          </a:solidFill>
-          <a:ln>
-            <a:noFill/>
-          </a:ln>
-          <a:effectLst/>
-        </p:spPr>
-        <p:style>
-          <a:lnRef idx="1">
-            <a:schemeClr val="accent1"/>
-          </a:lnRef>
-          <a:fillRef idx="3">
-            <a:schemeClr val="accent1"/>
-          </a:fillRef>
-          <a:effectRef idx="2">
-            <a:schemeClr val="accent1"/>
-          </a:effectRef>
-          <a:fontRef idx="minor">
-            <a:schemeClr val="lt1"/>
-          </a:fontRef>
-        </p:style>
-        <p:txBody>
-          <a:bodyPr rtlCol="0" anchor="ctr"/>
-          <a:lstStyle/>
-          <a:p>
-            <a:pPr algn="ctr"/>
-          </a:p>
-        </p:txBody>
-      </p:sp>
-      <p:sp>
-        <p:nvSpPr>
-          <p:cNvPr id="11" name="TextBox 10"/>
-          <p:cNvSpPr txBox="1"/>
-          <p:nvPr/>
-        </p:nvSpPr>
-        <p:spPr>
-          <a:xfrm>
-            <a:off x="6373368" y="3858768"/>
-            <a:ext cx="5029200" cy="1746504"/>
-          </a:xfrm>
-          <a:prstGeom prst="rect">
-            <a:avLst/>
-          </a:prstGeom>
-          <a:noFill/>
-        </p:spPr>
-        <p:txBody>
-          <a:bodyPr wrap="square" lIns="45720" rIns="45720" tIns="27432" bIns="27432" anchor="t">
-            <a:spAutoFit/>
-          </a:bodyPr>
-          <a:lstStyle/>
-          <a:p>
-            <a:pPr algn="l">
-              <a:spcAft>
-                <a:spcPts val="600"/>
-              </a:spcAft>
-            </a:pPr>
-            <a:r>
-              <a:rPr sz="2000" b="1" i="0">
-                <a:solidFill>
-                  <a:srgbClr val="2B4EB4"/>
-                </a:solidFill>
-                <a:latin typeface="Calibri"/>
-              </a:rPr>
-              <a:t>Verificación humana</a:t>
-            </a:r>
-          </a:p>
-          <a:p>
-            <a:pPr algn="l">
-              <a:spcAft>
-                <a:spcPts val="400"/>
-              </a:spcAft>
-            </a:pPr>
-            <a:r>
-              <a:rPr sz="1800" b="0" i="0">
-                <a:solidFill>
-                  <a:srgbClr val="011754"/>
-                </a:solidFill>
-                <a:latin typeface="Calibri"/>
-              </a:rPr>
-              <a:t>Tú compruebas que cada fuente exista y responda al tema.</a:t>
-            </a:r>
-          </a:p>
-        </p:txBody>
-      </p:sp>
-      <p:sp>
-        <p:nvSpPr>
-          <p:cNvPr id="12" name="Rounded Rectangle 11"/>
-          <p:cNvSpPr/>
-          <p:nvPr/>
-        </p:nvSpPr>
-        <p:spPr>
-          <a:xfrm>
-            <a:off x="612648" y="5486400"/>
-            <a:ext cx="10972800" cy="640080"/>
-          </a:xfrm>
-          <a:prstGeom prst="roundRect">
-            <a:avLst>
-              <a:gd name="adj" fmla="val 6000"/>
-            </a:avLst>
-          </a:prstGeom>
-          <a:solidFill>
-            <a:srgbClr val="011754"/>
-          </a:solidFill>
-          <a:ln>
-            <a:noFill/>
-          </a:ln>
-          <a:effectLst/>
-        </p:spPr>
-        <p:style>
-          <a:lnRef idx="1">
-            <a:schemeClr val="accent1"/>
-          </a:lnRef>
-          <a:fillRef idx="3">
-            <a:schemeClr val="accent1"/>
-          </a:fillRef>
-          <a:effectRef idx="2">
-            <a:schemeClr val="accent1"/>
-          </a:effectRef>
-          <a:fontRef idx="minor">
-            <a:schemeClr val="lt1"/>
-          </a:fontRef>
-        </p:style>
-        <p:txBody>
-          <a:bodyPr rtlCol="0" anchor="ctr"/>
-          <a:lstStyle/>
-          <a:p>
-            <a:pPr algn="ctr"/>
-          </a:p>
-        </p:txBody>
-      </p:sp>
-      <p:sp>
-        <p:nvSpPr>
-          <p:cNvPr id="13" name="TextBox 12"/>
-          <p:cNvSpPr txBox="1"/>
-          <p:nvPr/>
-        </p:nvSpPr>
-        <p:spPr>
-          <a:xfrm>
-            <a:off x="841248" y="5486400"/>
-            <a:ext cx="10515600" cy="640080"/>
-          </a:xfrm>
-          <a:prstGeom prst="rect">
-            <a:avLst/>
-          </a:prstGeom>
-          <a:noFill/>
-        </p:spPr>
-        <p:txBody>
-          <a:bodyPr wrap="square" lIns="45720" rIns="45720" tIns="27432" bIns="27432" anchor="ctr">
-            <a:spAutoFit/>
-          </a:bodyPr>
-          <a:lstStyle/>
-          <a:p>
-            <a:pPr algn="l">
-              <a:spcAft>
-                <a:spcPts val="400"/>
-              </a:spcAft>
-            </a:pPr>
-            <a:r>
-              <a:rPr sz="1800" b="1" i="0">
-                <a:solidFill>
-                  <a:srgbClr val="FFFFFF"/>
-                </a:solidFill>
-                <a:latin typeface="Calibri"/>
-              </a:rPr>
-              <a:t>Pide sinónimos y equivalencias; luego ejecuta y verifica la cadena en Google Scholar.</a:t>
+              <a:t>Google Scholar recupera fuentes; la IA amplía el vocabulario. Una fuente que muestra la IA no es evidencia hasta comprobarla.</a:t>
             </a:r>
           </a:p>
         </p:txBody>
@@ -21305,572 +17701,6 @@
 </p:sld>
 </file>
 
-<file path=ppt/slides/slide5.xml><?xml version="1.0" encoding="utf-8"?>
-<p:sld xmlns:a="http://schemas.openxmlformats.org/drawingml/2006/main" xmlns:r="http://schemas.openxmlformats.org/officeDocument/2006/relationships" xmlns:p="http://schemas.openxmlformats.org/presentationml/2006/main">
-  <p:cSld>
-    <p:spTree>
-      <p:nvGrpSpPr>
-        <p:cNvPr id="1" name=""/>
-        <p:cNvGrpSpPr/>
-        <p:nvPr/>
-      </p:nvGrpSpPr>
-      <p:grpSpPr>
-        <a:xfrm>
-          <a:off x="0" y="0"/>
-          <a:ext cx="0" cy="0"/>
-          <a:chOff x="0" y="0"/>
-          <a:chExt cx="0" cy="0"/>
-        </a:xfrm>
-      </p:grpSpPr>
-      <p:pic>
-        <p:nvPicPr>
-          <p:cNvPr id="2" name="Picture 1" descr="divider_bg.png"/>
-          <p:cNvPicPr>
-            <a:picLocks noChangeAspect="1"/>
-          </p:cNvPicPr>
-          <p:nvPr/>
-        </p:nvPicPr>
-        <p:blipFill>
-          <a:blip r:embed="rId2"/>
-          <a:stretch>
-            <a:fillRect/>
-          </a:stretch>
-        </p:blipFill>
-        <p:spPr>
-          <a:xfrm>
-            <a:off x="0" y="0"/>
-            <a:ext cx="12191695" cy="6858000"/>
-          </a:xfrm>
-          <a:prstGeom prst="rect">
-            <a:avLst/>
-          </a:prstGeom>
-        </p:spPr>
-      </p:pic>
-      <p:sp>
-        <p:nvSpPr>
-          <p:cNvPr id="3" name="TextBox 2"/>
-          <p:cNvSpPr txBox="1"/>
-          <p:nvPr/>
-        </p:nvSpPr>
-        <p:spPr>
-          <a:xfrm>
-            <a:off x="982912" y="2676125"/>
-            <a:ext cx="437840" cy="1999910"/>
-          </a:xfrm>
-          <a:prstGeom prst="rect">
-            <a:avLst/>
-          </a:prstGeom>
-          <a:noFill/>
-        </p:spPr>
-        <p:txBody>
-          <a:bodyPr wrap="square">
-            <a:spAutoFit/>
-          </a:bodyPr>
-          <a:lstStyle/>
-          <a:p>
-            <a:pPr algn="l">
-              <a:lnSpc>
-                <a:spcPct val="115000"/>
-              </a:lnSpc>
-            </a:pPr>
-            <a:r>
-              <a:rPr sz="7200" b="1" i="0">
-                <a:solidFill>
-                  <a:srgbClr val="FFFFFF"/>
-                </a:solidFill>
-                <a:latin typeface="Calibri"/>
-              </a:rPr>
-              <a:t>1</a:t>
-            </a:r>
-          </a:p>
-        </p:txBody>
-      </p:sp>
-      <p:sp>
-        <p:nvSpPr>
-          <p:cNvPr id="4" name="TextBox 3"/>
-          <p:cNvSpPr txBox="1"/>
-          <p:nvPr/>
-        </p:nvSpPr>
-        <p:spPr>
-          <a:xfrm>
-            <a:off x="982912" y="4737409"/>
-            <a:ext cx="10346277" cy="702221"/>
-          </a:xfrm>
-          <a:prstGeom prst="rect">
-            <a:avLst/>
-          </a:prstGeom>
-          <a:noFill/>
-        </p:spPr>
-        <p:txBody>
-          <a:bodyPr wrap="square">
-            <a:spAutoFit/>
-          </a:bodyPr>
-          <a:lstStyle/>
-          <a:p>
-            <a:pPr algn="l">
-              <a:lnSpc>
-                <a:spcPct val="115000"/>
-              </a:lnSpc>
-            </a:pPr>
-            <a:r>
-              <a:rPr sz="2600" b="0" i="0">
-                <a:solidFill>
-                  <a:srgbClr val="FFFFFF"/>
-                </a:solidFill>
-                <a:latin typeface="Calibri"/>
-              </a:rPr>
-              <a:t>FUNDAMENTOS Y VOCABULARIO DE BÚSQUEDA</a:t>
-            </a:r>
-          </a:p>
-        </p:txBody>
-      </p:sp>
-    </p:spTree>
-  </p:cSld>
-  <p:clrMapOvr>
-    <a:masterClrMapping/>
-  </p:clrMapOvr>
-</p:sld>
-</file>
-
-<file path=ppt/slides/slide50.xml><?xml version="1.0" encoding="utf-8"?>
-<p:sld xmlns:a="http://schemas.openxmlformats.org/drawingml/2006/main" xmlns:p="http://schemas.openxmlformats.org/presentationml/2006/main" xmlns:r="http://schemas.openxmlformats.org/officeDocument/2006/relationships">
-  <p:cSld>
-    <p:spTree>
-      <p:nvGrpSpPr>
-        <p:cNvPr id="1" name=""/>
-        <p:cNvGrpSpPr/>
-        <p:nvPr/>
-      </p:nvGrpSpPr>
-      <p:grpSpPr/>
-      <p:pic>
-        <p:nvPicPr>
-          <p:cNvPr id="2" name="Picture 1" descr="image.png"/>
-          <p:cNvPicPr>
-            <a:picLocks noChangeAspect="1"/>
-          </p:cNvPicPr>
-          <p:nvPr/>
-        </p:nvPicPr>
-        <p:blipFill>
-          <a:blip r:embed="rId2"/>
-          <a:stretch>
-            <a:fillRect/>
-          </a:stretch>
-        </p:blipFill>
-        <p:spPr>
-          <a:xfrm>
-            <a:off x="0" y="0"/>
-            <a:ext cx="12192000" cy="6858000"/>
-          </a:xfrm>
-          <a:prstGeom prst="rect">
-            <a:avLst/>
-          </a:prstGeom>
-        </p:spPr>
-      </p:pic>
-      <p:sp>
-        <p:nvSpPr>
-          <p:cNvPr id="3" name="TextBox 2"/>
-          <p:cNvSpPr txBox="1"/>
-          <p:nvPr/>
-        </p:nvSpPr>
-        <p:spPr>
-          <a:xfrm>
-            <a:off x="612648" y="777240"/>
-            <a:ext cx="10332720" cy="640080"/>
-          </a:xfrm>
-          <a:prstGeom prst="rect">
-            <a:avLst/>
-          </a:prstGeom>
-          <a:noFill/>
-        </p:spPr>
-        <p:txBody>
-          <a:bodyPr wrap="square" lIns="45720" rIns="45720" tIns="27432" bIns="27432" anchor="ctr">
-            <a:spAutoFit/>
-          </a:bodyPr>
-          <a:lstStyle/>
-          <a:p>
-            <a:pPr algn="l">
-              <a:spcAft>
-                <a:spcPts val="400"/>
-              </a:spcAft>
-            </a:pPr>
-            <a:r>
-              <a:rPr sz="2800" b="1" i="0">
-                <a:solidFill>
-                  <a:srgbClr val="1836B2"/>
-                </a:solidFill>
-                <a:latin typeface="Calibri"/>
-              </a:rPr>
-              <a:t>El reto: una búsqueda que hoy no funciona</a:t>
-            </a:r>
-          </a:p>
-        </p:txBody>
-      </p:sp>
-      <p:sp>
-        <p:nvSpPr>
-          <p:cNvPr id="4" name="TextBox 3"/>
-          <p:cNvSpPr txBox="1"/>
-          <p:nvPr/>
-        </p:nvSpPr>
-        <p:spPr>
-          <a:xfrm>
-            <a:off x="612648" y="1463040"/>
-            <a:ext cx="10972800" cy="731520"/>
-          </a:xfrm>
-          <a:prstGeom prst="rect">
-            <a:avLst/>
-          </a:prstGeom>
-          <a:noFill/>
-        </p:spPr>
-        <p:txBody>
-          <a:bodyPr wrap="square" lIns="45720" rIns="45720" tIns="27432" bIns="27432" anchor="t">
-            <a:spAutoFit/>
-          </a:bodyPr>
-          <a:lstStyle/>
-          <a:p>
-            <a:pPr algn="l">
-              <a:spcAft>
-                <a:spcPts val="400"/>
-              </a:spcAft>
-            </a:pPr>
-            <a:r>
-              <a:rPr sz="1800" b="1" i="0">
-                <a:solidFill>
-                  <a:srgbClr val="011754"/>
-                </a:solidFill>
-                <a:latin typeface="Calibri"/>
-              </a:rPr>
-              <a:t>Una investigadora estudia la relación entre herramientas de IA generativa y aprendizaje autónomo en estudiantes universitarios.</a:t>
-            </a:r>
-          </a:p>
-        </p:txBody>
-      </p:sp>
-      <p:sp>
-        <p:nvSpPr>
-          <p:cNvPr id="5" name="Rounded Rectangle 4"/>
-          <p:cNvSpPr/>
-          <p:nvPr/>
-        </p:nvSpPr>
-        <p:spPr>
-          <a:xfrm>
-            <a:off x="612648" y="2331720"/>
-            <a:ext cx="5394960" cy="2240280"/>
-          </a:xfrm>
-          <a:prstGeom prst="roundRect">
-            <a:avLst>
-              <a:gd name="adj" fmla="val 6000"/>
-            </a:avLst>
-          </a:prstGeom>
-          <a:solidFill>
-            <a:srgbClr val="F6ECC8"/>
-          </a:solidFill>
-          <a:ln>
-            <a:noFill/>
-          </a:ln>
-          <a:effectLst/>
-        </p:spPr>
-        <p:style>
-          <a:lnRef idx="1">
-            <a:schemeClr val="accent1"/>
-          </a:lnRef>
-          <a:fillRef idx="3">
-            <a:schemeClr val="accent1"/>
-          </a:fillRef>
-          <a:effectRef idx="2">
-            <a:schemeClr val="accent1"/>
-          </a:effectRef>
-          <a:fontRef idx="minor">
-            <a:schemeClr val="lt1"/>
-          </a:fontRef>
-        </p:style>
-        <p:txBody>
-          <a:bodyPr rtlCol="0" anchor="ctr"/>
-          <a:lstStyle/>
-          <a:p>
-            <a:pPr algn="ctr"/>
-          </a:p>
-        </p:txBody>
-      </p:sp>
-      <p:sp>
-        <p:nvSpPr>
-          <p:cNvPr id="6" name="TextBox 5"/>
-          <p:cNvSpPr txBox="1"/>
-          <p:nvPr/>
-        </p:nvSpPr>
-        <p:spPr>
-          <a:xfrm>
-            <a:off x="795528" y="2441448"/>
-            <a:ext cx="5029200" cy="2020824"/>
-          </a:xfrm>
-          <a:prstGeom prst="rect">
-            <a:avLst/>
-          </a:prstGeom>
-          <a:noFill/>
-        </p:spPr>
-        <p:txBody>
-          <a:bodyPr wrap="square" lIns="45720" rIns="45720" tIns="27432" bIns="27432" anchor="t">
-            <a:spAutoFit/>
-          </a:bodyPr>
-          <a:lstStyle/>
-          <a:p>
-            <a:pPr algn="l">
-              <a:spcAft>
-                <a:spcPts val="600"/>
-              </a:spcAft>
-            </a:pPr>
-            <a:r>
-              <a:rPr sz="2000" b="1" i="0">
-                <a:solidFill>
-                  <a:srgbClr val="8A5A00"/>
-                </a:solidFill>
-                <a:latin typeface="Calibri"/>
-              </a:rPr>
-              <a:t>Lo que le pasa</a:t>
-            </a:r>
-          </a:p>
-          <a:p>
-            <a:pPr algn="l">
-              <a:spcAft>
-                <a:spcPts val="400"/>
-              </a:spcAft>
-            </a:pPr>
-            <a:r>
-              <a:rPr sz="1800" b="0" i="0">
-                <a:solidFill>
-                  <a:srgbClr val="011754"/>
-                </a:solidFill>
-                <a:latin typeface="Calibri"/>
-              </a:rPr>
-              <a:t>Recupera noticias y blogs.</a:t>
-            </a:r>
-          </a:p>
-          <a:p>
-            <a:pPr algn="l">
-              <a:spcAft>
-                <a:spcPts val="400"/>
-              </a:spcAft>
-            </a:pPr>
-            <a:r>
-              <a:rPr sz="1800" b="0" i="0">
-                <a:solidFill>
-                  <a:srgbClr val="011754"/>
-                </a:solidFill>
-                <a:latin typeface="Calibri"/>
-              </a:rPr>
-              <a:t>Obtiene documentos poco relacionados.</a:t>
-            </a:r>
-          </a:p>
-        </p:txBody>
-      </p:sp>
-      <p:sp>
-        <p:nvSpPr>
-          <p:cNvPr id="7" name="Rounded Rectangle 6"/>
-          <p:cNvSpPr/>
-          <p:nvPr/>
-        </p:nvSpPr>
-        <p:spPr>
-          <a:xfrm>
-            <a:off x="6190488" y="2331720"/>
-            <a:ext cx="5394960" cy="2240280"/>
-          </a:xfrm>
-          <a:prstGeom prst="roundRect">
-            <a:avLst>
-              <a:gd name="adj" fmla="val 6000"/>
-            </a:avLst>
-          </a:prstGeom>
-          <a:solidFill>
-            <a:srgbClr val="F6ECC8"/>
-          </a:solidFill>
-          <a:ln>
-            <a:noFill/>
-          </a:ln>
-          <a:effectLst/>
-        </p:spPr>
-        <p:style>
-          <a:lnRef idx="1">
-            <a:schemeClr val="accent1"/>
-          </a:lnRef>
-          <a:fillRef idx="3">
-            <a:schemeClr val="accent1"/>
-          </a:fillRef>
-          <a:effectRef idx="2">
-            <a:schemeClr val="accent1"/>
-          </a:effectRef>
-          <a:fontRef idx="minor">
-            <a:schemeClr val="lt1"/>
-          </a:fontRef>
-        </p:style>
-        <p:txBody>
-          <a:bodyPr rtlCol="0" anchor="ctr"/>
-          <a:lstStyle/>
-          <a:p>
-            <a:pPr algn="ctr"/>
-          </a:p>
-        </p:txBody>
-      </p:sp>
-      <p:sp>
-        <p:nvSpPr>
-          <p:cNvPr id="8" name="TextBox 7"/>
-          <p:cNvSpPr txBox="1"/>
-          <p:nvPr/>
-        </p:nvSpPr>
-        <p:spPr>
-          <a:xfrm>
-            <a:off x="6373368" y="2441448"/>
-            <a:ext cx="5029200" cy="2020824"/>
-          </a:xfrm>
-          <a:prstGeom prst="rect">
-            <a:avLst/>
-          </a:prstGeom>
-          <a:noFill/>
-        </p:spPr>
-        <p:txBody>
-          <a:bodyPr wrap="square" lIns="45720" rIns="45720" tIns="27432" bIns="27432" anchor="t">
-            <a:spAutoFit/>
-          </a:bodyPr>
-          <a:lstStyle/>
-          <a:p>
-            <a:pPr algn="l">
-              <a:spcAft>
-                <a:spcPts val="600"/>
-              </a:spcAft>
-            </a:pPr>
-            <a:r>
-              <a:rPr sz="2000" b="1" i="0">
-                <a:solidFill>
-                  <a:srgbClr val="8A5A00"/>
-                </a:solidFill>
-                <a:latin typeface="Calibri"/>
-              </a:rPr>
-              <a:t>Lo que no sabe</a:t>
-            </a:r>
-          </a:p>
-          <a:p>
-            <a:pPr algn="l">
-              <a:spcAft>
-                <a:spcPts val="400"/>
-              </a:spcAft>
-            </a:pPr>
-            <a:r>
-              <a:rPr sz="1800" b="0" i="0">
-                <a:solidFill>
-                  <a:srgbClr val="011754"/>
-                </a:solidFill>
-                <a:latin typeface="Calibri"/>
-              </a:rPr>
-              <a:t>Si las sugerencias de la IA son académicas.</a:t>
-            </a:r>
-          </a:p>
-          <a:p>
-            <a:pPr algn="l">
-              <a:spcAft>
-                <a:spcPts val="400"/>
-              </a:spcAft>
-            </a:pPr>
-            <a:r>
-              <a:rPr sz="1800" b="0" i="0">
-                <a:solidFill>
-                  <a:srgbClr val="011754"/>
-                </a:solidFill>
-                <a:latin typeface="Calibri"/>
-              </a:rPr>
-              <a:t>Cómo repetir su búsqueda.</a:t>
-            </a:r>
-          </a:p>
-        </p:txBody>
-      </p:sp>
-      <p:sp>
-        <p:nvSpPr>
-          <p:cNvPr id="9" name="Rounded Rectangle 8"/>
-          <p:cNvSpPr/>
-          <p:nvPr/>
-        </p:nvSpPr>
-        <p:spPr>
-          <a:xfrm>
-            <a:off x="612648" y="4846320"/>
-            <a:ext cx="10972800" cy="822960"/>
-          </a:xfrm>
-          <a:prstGeom prst="roundRect">
-            <a:avLst>
-              <a:gd name="adj" fmla="val 6000"/>
-            </a:avLst>
-          </a:prstGeom>
-          <a:solidFill>
-            <a:srgbClr val="011754"/>
-          </a:solidFill>
-          <a:ln>
-            <a:noFill/>
-          </a:ln>
-          <a:effectLst/>
-        </p:spPr>
-        <p:style>
-          <a:lnRef idx="1">
-            <a:schemeClr val="accent1"/>
-          </a:lnRef>
-          <a:fillRef idx="3">
-            <a:schemeClr val="accent1"/>
-          </a:fillRef>
-          <a:effectRef idx="2">
-            <a:schemeClr val="accent1"/>
-          </a:effectRef>
-          <a:fontRef idx="minor">
-            <a:schemeClr val="lt1"/>
-          </a:fontRef>
-        </p:style>
-        <p:txBody>
-          <a:bodyPr rtlCol="0" anchor="ctr"/>
-          <a:lstStyle/>
-          <a:p>
-            <a:pPr algn="ctr"/>
-          </a:p>
-        </p:txBody>
-      </p:sp>
-      <p:sp>
-        <p:nvSpPr>
-          <p:cNvPr id="10" name="TextBox 9"/>
-          <p:cNvSpPr txBox="1"/>
-          <p:nvPr/>
-        </p:nvSpPr>
-        <p:spPr>
-          <a:xfrm>
-            <a:off x="841248" y="4846320"/>
-            <a:ext cx="10515600" cy="822960"/>
-          </a:xfrm>
-          <a:prstGeom prst="rect">
-            <a:avLst/>
-          </a:prstGeom>
-          <a:noFill/>
-        </p:spPr>
-        <p:txBody>
-          <a:bodyPr wrap="square" lIns="45720" rIns="45720" tIns="27432" bIns="27432" anchor="ctr">
-            <a:spAutoFit/>
-          </a:bodyPr>
-          <a:lstStyle/>
-          <a:p>
-            <a:pPr algn="l">
-              <a:spcAft>
-                <a:spcPts val="400"/>
-              </a:spcAft>
-            </a:pPr>
-            <a:r>
-              <a:rPr sz="1800" b="1" i="0">
-                <a:solidFill>
-                  <a:srgbClr val="FFFFFF"/>
-                </a:solidFill>
-                <a:latin typeface="Calibri"/>
-              </a:rPr>
-              <a:t>Su tarea: construir una estrategia de búsqueda reproducible, paso a paso.</a:t>
-            </a:r>
-          </a:p>
-        </p:txBody>
-      </p:sp>
-    </p:spTree>
-  </p:cSld>
-  <p:clrMapOvr>
-    <a:masterClrMapping/>
-  </p:clrMapOvr>
-</p:sld>
-</file>
-
 <file path=ppt/slides/slide51.xml><?xml version="1.0" encoding="utf-8"?>
 <p:sld xmlns:a="http://schemas.openxmlformats.org/drawingml/2006/main" xmlns:p="http://schemas.openxmlformats.org/presentationml/2006/main" xmlns:r="http://schemas.openxmlformats.org/officeDocument/2006/relationships">
   <p:cSld>
@@ -21953,7 +17783,7 @@
         <p:spPr>
           <a:xfrm>
             <a:off x="612648" y="1463040"/>
-            <a:ext cx="10972800" cy="457200"/>
+            <a:ext cx="10972800" cy="731520"/>
           </a:xfrm>
           <a:prstGeom prst="rect">
             <a:avLst/>
@@ -21978,7 +17808,7 @@
                 </a:solidFill>
                 <a:latin typeface="Calibri"/>
               </a:rPr>
-              <a:t>Antes de usar cualquier herramienta, completa la matriz de delimitación (sin IA).</a:t>
+              <a:t>Caso: una investigadora estudia IA generativa y aprendizaje autónomo, pero su búsqueda trae noticias y blogs. Antes de usar cualquier herramienta, completa la matriz de delimitación (sin IA).</a:t>
             </a:r>
           </a:p>
         </p:txBody>
@@ -21992,8 +17822,8 @@
           <p:nvPr/>
         </p:nvGraphicFramePr>
         <p:xfrm>
-          <a:off x="612648" y="2011680"/>
-          <a:ext cx="10972800" cy="3840480"/>
+          <a:off x="612648" y="2331720"/>
+          <a:ext cx="10972800" cy="3657600"/>
         </p:xfrm>
         <a:graphic>
           <a:graphicData uri="http://schemas.openxmlformats.org/drawingml/2006/table">
@@ -22053,7 +17883,7 @@
                   </a:tcPr>
                 </a:tc>
               </a:tr>
-              <a:tr h="822960">
+              <a:tr h="777240">
                 <a:tc>
                   <a:txBody>
                     <a:bodyPr wrap="square"/>
@@ -22101,7 +17931,7 @@
                   </a:tcPr>
                 </a:tc>
               </a:tr>
-              <a:tr h="822960">
+              <a:tr h="777240">
                 <a:tc>
                   <a:txBody>
                     <a:bodyPr wrap="square"/>
@@ -22149,7 +17979,7 @@
                   </a:tcPr>
                 </a:tc>
               </a:tr>
-              <a:tr h="822960">
+              <a:tr h="777240">
                 <a:tc>
                   <a:txBody>
                     <a:bodyPr wrap="square"/>
@@ -22197,7 +18027,7 @@
                   </a:tcPr>
                 </a:tc>
               </a:tr>
-              <a:tr h="822960">
+              <a:tr h="777240">
                 <a:tc>
                   <a:txBody>
                     <a:bodyPr wrap="square"/>
@@ -25235,424 +21065,6 @@
                 <a:latin typeface="Calibri"/>
               </a:rPr>
               <a:t>Si no puedo explicar cómo encontré una fuente, la búsqueda no está documentada.</a:t>
-            </a:r>
-          </a:p>
-        </p:txBody>
-      </p:sp>
-    </p:spTree>
-  </p:cSld>
-  <p:clrMapOvr>
-    <a:masterClrMapping/>
-  </p:clrMapOvr>
-</p:sld>
-</file>
-
-<file path=ppt/slides/slide58.xml><?xml version="1.0" encoding="utf-8"?>
-<p:sld xmlns:a="http://schemas.openxmlformats.org/drawingml/2006/main" xmlns:p="http://schemas.openxmlformats.org/presentationml/2006/main" xmlns:r="http://schemas.openxmlformats.org/officeDocument/2006/relationships">
-  <p:cSld>
-    <p:spTree>
-      <p:nvGrpSpPr>
-        <p:cNvPr id="1" name=""/>
-        <p:cNvGrpSpPr/>
-        <p:nvPr/>
-      </p:nvGrpSpPr>
-      <p:grpSpPr/>
-      <p:pic>
-        <p:nvPicPr>
-          <p:cNvPr id="2" name="Picture 1" descr="image.png"/>
-          <p:cNvPicPr>
-            <a:picLocks noChangeAspect="1"/>
-          </p:cNvPicPr>
-          <p:nvPr/>
-        </p:nvPicPr>
-        <p:blipFill>
-          <a:blip r:embed="rId2"/>
-          <a:stretch>
-            <a:fillRect/>
-          </a:stretch>
-        </p:blipFill>
-        <p:spPr>
-          <a:xfrm>
-            <a:off x="0" y="0"/>
-            <a:ext cx="12192000" cy="6858000"/>
-          </a:xfrm>
-          <a:prstGeom prst="rect">
-            <a:avLst/>
-          </a:prstGeom>
-        </p:spPr>
-      </p:pic>
-      <p:sp>
-        <p:nvSpPr>
-          <p:cNvPr id="3" name="TextBox 2"/>
-          <p:cNvSpPr txBox="1"/>
-          <p:nvPr/>
-        </p:nvSpPr>
-        <p:spPr>
-          <a:xfrm>
-            <a:off x="612648" y="777240"/>
-            <a:ext cx="10332720" cy="640080"/>
-          </a:xfrm>
-          <a:prstGeom prst="rect">
-            <a:avLst/>
-          </a:prstGeom>
-          <a:noFill/>
-        </p:spPr>
-        <p:txBody>
-          <a:bodyPr wrap="square" lIns="45720" rIns="45720" tIns="27432" bIns="27432" anchor="ctr">
-            <a:spAutoFit/>
-          </a:bodyPr>
-          <a:lstStyle/>
-          <a:p>
-            <a:pPr algn="l">
-              <a:spcAft>
-                <a:spcPts val="400"/>
-              </a:spcAft>
-            </a:pPr>
-            <a:r>
-              <a:rPr sz="2800" b="1" i="0">
-                <a:solidFill>
-                  <a:srgbClr val="1836B2"/>
-                </a:solidFill>
-                <a:latin typeface="Calibri"/>
-              </a:rPr>
-              <a:t>La decisión final pertenece al investigador</a:t>
-            </a:r>
-          </a:p>
-        </p:txBody>
-      </p:sp>
-      <p:sp>
-        <p:nvSpPr>
-          <p:cNvPr id="4" name="Rounded Rectangle 3"/>
-          <p:cNvSpPr/>
-          <p:nvPr/>
-        </p:nvSpPr>
-        <p:spPr>
-          <a:xfrm>
-            <a:off x="612648" y="1600200"/>
-            <a:ext cx="5394960" cy="4206240"/>
-          </a:xfrm>
-          <a:prstGeom prst="roundRect">
-            <a:avLst>
-              <a:gd name="adj" fmla="val 6000"/>
-            </a:avLst>
-          </a:prstGeom>
-          <a:solidFill>
-            <a:srgbClr val="D9DEEF"/>
-          </a:solidFill>
-          <a:ln>
-            <a:noFill/>
-          </a:ln>
-          <a:effectLst/>
-        </p:spPr>
-        <p:style>
-          <a:lnRef idx="1">
-            <a:schemeClr val="accent1"/>
-          </a:lnRef>
-          <a:fillRef idx="3">
-            <a:schemeClr val="accent1"/>
-          </a:fillRef>
-          <a:effectRef idx="2">
-            <a:schemeClr val="accent1"/>
-          </a:effectRef>
-          <a:fontRef idx="minor">
-            <a:schemeClr val="lt1"/>
-          </a:fontRef>
-        </p:style>
-        <p:txBody>
-          <a:bodyPr rtlCol="0" anchor="ctr"/>
-          <a:lstStyle/>
-          <a:p>
-            <a:pPr algn="ctr"/>
-          </a:p>
-        </p:txBody>
-      </p:sp>
-      <p:sp>
-        <p:nvSpPr>
-          <p:cNvPr id="5" name="TextBox 4"/>
-          <p:cNvSpPr txBox="1"/>
-          <p:nvPr/>
-        </p:nvSpPr>
-        <p:spPr>
-          <a:xfrm>
-            <a:off x="841248" y="1691640"/>
-            <a:ext cx="4937760" cy="4023360"/>
-          </a:xfrm>
-          <a:prstGeom prst="rect">
-            <a:avLst/>
-          </a:prstGeom>
-          <a:noFill/>
-        </p:spPr>
-        <p:txBody>
-          <a:bodyPr wrap="square" lIns="45720" rIns="45720" tIns="27432" bIns="27432" anchor="t">
-            <a:spAutoFit/>
-          </a:bodyPr>
-          <a:lstStyle/>
-          <a:p>
-            <a:pPr algn="l">
-              <a:spcAft>
-                <a:spcPts val="800"/>
-              </a:spcAft>
-            </a:pPr>
-            <a:r>
-              <a:rPr sz="2000" b="1" i="0">
-                <a:solidFill>
-                  <a:srgbClr val="2B4EB4"/>
-                </a:solidFill>
-                <a:latin typeface="Calibri"/>
-              </a:rPr>
-              <a:t>La IA puede</a:t>
-            </a:r>
-          </a:p>
-          <a:p>
-            <a:pPr algn="l">
-              <a:spcAft>
-                <a:spcPts val="600"/>
-              </a:spcAft>
-            </a:pPr>
-            <a:r>
-              <a:rPr sz="1800" b="0" i="0">
-                <a:solidFill>
-                  <a:srgbClr val="011754"/>
-                </a:solidFill>
-                <a:latin typeface="Calibri"/>
-              </a:rPr>
-              <a:t>• Sugerir términos alternativos y sinónimos.</a:t>
-            </a:r>
-          </a:p>
-          <a:p>
-            <a:pPr algn="l">
-              <a:spcAft>
-                <a:spcPts val="600"/>
-              </a:spcAft>
-            </a:pPr>
-            <a:r>
-              <a:rPr sz="1800" b="0" i="0">
-                <a:solidFill>
-                  <a:srgbClr val="011754"/>
-                </a:solidFill>
-                <a:latin typeface="Calibri"/>
-              </a:rPr>
-              <a:t>• Explorar conexiones iniciales.</a:t>
-            </a:r>
-          </a:p>
-          <a:p>
-            <a:pPr algn="l">
-              <a:spcAft>
-                <a:spcPts val="600"/>
-              </a:spcAft>
-            </a:pPr>
-            <a:r>
-              <a:rPr sz="1800" b="0" i="0">
-                <a:solidFill>
-                  <a:srgbClr val="011754"/>
-                </a:solidFill>
-                <a:latin typeface="Calibri"/>
-              </a:rPr>
-              <a:t>• Organizar tablas preliminares.</a:t>
-            </a:r>
-          </a:p>
-          <a:p>
-            <a:pPr algn="l">
-              <a:spcAft>
-                <a:spcPts val="400"/>
-              </a:spcAft>
-            </a:pPr>
-            <a:r>
-              <a:rPr sz="1800" b="0" i="0">
-                <a:solidFill>
-                  <a:srgbClr val="011754"/>
-                </a:solidFill>
-                <a:latin typeface="Calibri"/>
-              </a:rPr>
-              <a:t>• Relacionar autores y literatura.</a:t>
-            </a:r>
-          </a:p>
-        </p:txBody>
-      </p:sp>
-      <p:sp>
-        <p:nvSpPr>
-          <p:cNvPr id="6" name="Rounded Rectangle 5"/>
-          <p:cNvSpPr/>
-          <p:nvPr/>
-        </p:nvSpPr>
-        <p:spPr>
-          <a:xfrm>
-            <a:off x="6190488" y="1600200"/>
-            <a:ext cx="5394960" cy="4206240"/>
-          </a:xfrm>
-          <a:prstGeom prst="roundRect">
-            <a:avLst>
-              <a:gd name="adj" fmla="val 6000"/>
-            </a:avLst>
-          </a:prstGeom>
-          <a:solidFill>
-            <a:srgbClr val="011754"/>
-          </a:solidFill>
-          <a:ln>
-            <a:noFill/>
-          </a:ln>
-          <a:effectLst/>
-        </p:spPr>
-        <p:style>
-          <a:lnRef idx="1">
-            <a:schemeClr val="accent1"/>
-          </a:lnRef>
-          <a:fillRef idx="3">
-            <a:schemeClr val="accent1"/>
-          </a:fillRef>
-          <a:effectRef idx="2">
-            <a:schemeClr val="accent1"/>
-          </a:effectRef>
-          <a:fontRef idx="minor">
-            <a:schemeClr val="lt1"/>
-          </a:fontRef>
-        </p:style>
-        <p:txBody>
-          <a:bodyPr rtlCol="0" anchor="ctr"/>
-          <a:lstStyle/>
-          <a:p>
-            <a:pPr algn="ctr"/>
-          </a:p>
-        </p:txBody>
-      </p:sp>
-      <p:sp>
-        <p:nvSpPr>
-          <p:cNvPr id="7" name="TextBox 6"/>
-          <p:cNvSpPr txBox="1"/>
-          <p:nvPr/>
-        </p:nvSpPr>
-        <p:spPr>
-          <a:xfrm>
-            <a:off x="6419088" y="1691640"/>
-            <a:ext cx="4937760" cy="4023360"/>
-          </a:xfrm>
-          <a:prstGeom prst="rect">
-            <a:avLst/>
-          </a:prstGeom>
-          <a:noFill/>
-        </p:spPr>
-        <p:txBody>
-          <a:bodyPr wrap="square" lIns="45720" rIns="45720" tIns="27432" bIns="27432" anchor="t">
-            <a:spAutoFit/>
-          </a:bodyPr>
-          <a:lstStyle/>
-          <a:p>
-            <a:pPr algn="l">
-              <a:spcAft>
-                <a:spcPts val="800"/>
-              </a:spcAft>
-            </a:pPr>
-            <a:r>
-              <a:rPr sz="2000" b="1" i="0">
-                <a:solidFill>
-                  <a:srgbClr val="D4AF37"/>
-                </a:solidFill>
-                <a:latin typeface="Calibri"/>
-              </a:rPr>
-              <a:t>El investigador debe</a:t>
-            </a:r>
-          </a:p>
-          <a:p>
-            <a:pPr algn="l">
-              <a:spcAft>
-                <a:spcPts val="600"/>
-              </a:spcAft>
-            </a:pPr>
-            <a:r>
-              <a:rPr sz="1800" b="0" i="0">
-                <a:solidFill>
-                  <a:srgbClr val="FFFFFF"/>
-                </a:solidFill>
-                <a:latin typeface="Calibri"/>
-              </a:rPr>
-              <a:t>• Evaluar la pertinencia real.</a:t>
-            </a:r>
-          </a:p>
-          <a:p>
-            <a:pPr algn="l">
-              <a:spcAft>
-                <a:spcPts val="600"/>
-              </a:spcAft>
-            </a:pPr>
-            <a:r>
-              <a:rPr sz="1800" b="0" i="0">
-                <a:solidFill>
-                  <a:srgbClr val="FFFFFF"/>
-                </a:solidFill>
-                <a:latin typeface="Calibri"/>
-              </a:rPr>
-              <a:t>• Verificar la autenticidad y el DOI.</a:t>
-            </a:r>
-          </a:p>
-          <a:p>
-            <a:pPr algn="l">
-              <a:spcAft>
-                <a:spcPts val="600"/>
-              </a:spcAft>
-            </a:pPr>
-            <a:r>
-              <a:rPr sz="1800" b="0" i="0">
-                <a:solidFill>
-                  <a:srgbClr val="FFFFFF"/>
-                </a:solidFill>
-                <a:latin typeface="Calibri"/>
-              </a:rPr>
-              <a:t>• Leer críticamente el texto completo.</a:t>
-            </a:r>
-          </a:p>
-          <a:p>
-            <a:pPr algn="l">
-              <a:spcAft>
-                <a:spcPts val="400"/>
-              </a:spcAft>
-            </a:pPr>
-            <a:r>
-              <a:rPr sz="1800" b="0" i="0">
-                <a:solidFill>
-                  <a:srgbClr val="FFFFFF"/>
-                </a:solidFill>
-                <a:latin typeface="Calibri"/>
-              </a:rPr>
-              <a:t>• Decidir qué se incluye y qué se excluye.</a:t>
-            </a:r>
-          </a:p>
-        </p:txBody>
-      </p:sp>
-      <p:sp>
-        <p:nvSpPr>
-          <p:cNvPr id="8" name="TextBox 7"/>
-          <p:cNvSpPr txBox="1"/>
-          <p:nvPr/>
-        </p:nvSpPr>
-        <p:spPr>
-          <a:xfrm>
-            <a:off x="612648" y="5897880"/>
-            <a:ext cx="10972800" cy="411480"/>
-          </a:xfrm>
-          <a:prstGeom prst="rect">
-            <a:avLst/>
-          </a:prstGeom>
-          <a:noFill/>
-        </p:spPr>
-        <p:txBody>
-          <a:bodyPr wrap="square" lIns="45720" rIns="45720" tIns="27432" bIns="27432" anchor="ctr">
-            <a:spAutoFit/>
-          </a:bodyPr>
-          <a:lstStyle/>
-          <a:p>
-            <a:pPr algn="l">
-              <a:spcAft>
-                <a:spcPts val="400"/>
-              </a:spcAft>
-            </a:pPr>
-            <a:r>
-              <a:rPr sz="1800" b="1" i="0">
-                <a:solidFill>
-                  <a:srgbClr val="2B4EB4"/>
-                </a:solidFill>
-                <a:latin typeface="Calibri"/>
-              </a:rPr>
-              <a:t>Asistencia tecnológica y juicio académico no son lo mismo.</a:t>
             </a:r>
           </a:p>
         </p:txBody>

</xml_diff>